<commit_message>
Clarify original totalVI dataset provenance
</commit_message>
<xml_diff>
--- a/deliverables/FusionVI_Final_Project_Presentation.pptx
+++ b/deliverables/FusionVI_Final_Project_Presentation.pptx
@@ -2,20 +2,20 @@
 <file path=ppt/presentation.xml><?xml version="1.0" encoding="utf-8"?>
 <p:presentation xmlns:p="http://schemas.openxmlformats.org/presentationml/2006/main">
   <p:sldMasterIdLst>
-    <p:sldMasterId xmlns:r="http://schemas.openxmlformats.org/officeDocument/2006/relationships" id="2147483648" r:id="R2701edbd3dd2421e"/>
+    <p:sldMasterId xmlns:r="http://schemas.openxmlformats.org/officeDocument/2006/relationships" id="2147483648" r:id="R565c8a32c57e4a08"/>
   </p:sldMasterIdLst>
   <p:notesMasterIdLst>
-    <p:notesMasterId xmlns:r="http://schemas.openxmlformats.org/officeDocument/2006/relationships" r:id="R80560154f40548da"/>
+    <p:notesMasterId xmlns:r="http://schemas.openxmlformats.org/officeDocument/2006/relationships" r:id="Rf1b1e6fd36394510"/>
   </p:notesMasterIdLst>
   <p:sldIdLst>
-    <p:sldId xmlns:r="http://schemas.openxmlformats.org/officeDocument/2006/relationships" id="256" r:id="R5e2bde8af84c4d95"/>
-    <p:sldId xmlns:r="http://schemas.openxmlformats.org/officeDocument/2006/relationships" id="257" r:id="Rf4f59a86b2f64ef0"/>
-    <p:sldId xmlns:r="http://schemas.openxmlformats.org/officeDocument/2006/relationships" id="258" r:id="Rfd37063f83624e83"/>
-    <p:sldId xmlns:r="http://schemas.openxmlformats.org/officeDocument/2006/relationships" id="259" r:id="R145690de67e64f70"/>
-    <p:sldId xmlns:r="http://schemas.openxmlformats.org/officeDocument/2006/relationships" id="260" r:id="R46b7e6ec1063440e"/>
-    <p:sldId xmlns:r="http://schemas.openxmlformats.org/officeDocument/2006/relationships" id="261" r:id="R82c17b04d7e544a3"/>
-    <p:sldId xmlns:r="http://schemas.openxmlformats.org/officeDocument/2006/relationships" id="262" r:id="R348bec4336ab42cb"/>
-    <p:sldId xmlns:r="http://schemas.openxmlformats.org/officeDocument/2006/relationships" id="263" r:id="R26445190d6f9488c"/>
+    <p:sldId xmlns:r="http://schemas.openxmlformats.org/officeDocument/2006/relationships" id="256" r:id="Rfc026c4a88a34f36"/>
+    <p:sldId xmlns:r="http://schemas.openxmlformats.org/officeDocument/2006/relationships" id="257" r:id="R8f586d022d1d45ec"/>
+    <p:sldId xmlns:r="http://schemas.openxmlformats.org/officeDocument/2006/relationships" id="258" r:id="R24917bee8e464301"/>
+    <p:sldId xmlns:r="http://schemas.openxmlformats.org/officeDocument/2006/relationships" id="259" r:id="R4fb865ba02384d7f"/>
+    <p:sldId xmlns:r="http://schemas.openxmlformats.org/officeDocument/2006/relationships" id="260" r:id="R526316c824c946d0"/>
+    <p:sldId xmlns:r="http://schemas.openxmlformats.org/officeDocument/2006/relationships" id="261" r:id="Rc9b3941a3a4845ad"/>
+    <p:sldId xmlns:r="http://schemas.openxmlformats.org/officeDocument/2006/relationships" id="262" r:id="R5d4224d358074bf8"/>
+    <p:sldId xmlns:r="http://schemas.openxmlformats.org/officeDocument/2006/relationships" id="263" r:id="Rc29c14b9a82e4b2f"/>
   </p:sldIdLst>
   <p:sldSz cx="12192000" cy="6858000"/>
   <p:notesSz cx="6858000" cy="9144000"/>
@@ -449,7 +449,7 @@
           <a:lstStyle xmlns:a="http://schemas.openxmlformats.org/drawingml/2006/main"/>
           <a:p xmlns:a="http://schemas.openxmlformats.org/drawingml/2006/main">
             <a:r>
-              <a:t>We compare only two final systems: the paper totalVI baseline and our model, FusionVI. The task is to recover four missing immune surface markers in a mouse never seen during training. Timing: 35 seconds.</a:t>
+              <a:t>This experiment uses the official SLN111 spleen and lymph-node CITE-seq object released with the totalVI paper. We compare only two final systems: the paper totalVI baseline and our model, FusionVI. The task is to recover four missing immune surface markers in a mouse never seen during training. Timing: 35 seconds.</a:t>
             </a:r>
           </a:p>
         </p:txBody>
@@ -1007,7 +1007,7 @@
   </p:cSld>
   <p:clrMap bg1="lt1" tx1="dk1" bg2="lt2" tx2="dk2" accent1="accent1" accent2="accent2" accent3="accent3" accent4="accent4" accent5="accent5" accent6="accent6" hlink="hlink" folHlink="folHlink"/>
   <p:sldLayoutIdLst>
-    <p:sldLayoutId xmlns:r="http://schemas.openxmlformats.org/officeDocument/2006/relationships" id="2147483649" r:id="Ra9f51302f32842bb"/>
+    <p:sldLayoutId xmlns:r="http://schemas.openxmlformats.org/officeDocument/2006/relationships" id="2147483649" r:id="R9ba971e6252442d3"/>
   </p:sldLayoutIdLst>
   <p:txStyles>
     <p:titleStyle>
@@ -1555,10 +1555,10 @@
       </p:grpSpPr>
       <p:sp>
         <p:nvSpPr>
-          <p:cNvPr id="19" name="">
-            <a:extLst xmlns:a="http://schemas.openxmlformats.org/drawingml/2006/main">
-              <a:ext uri="{FF2B5EF4-FFF2-40B4-BE49-F238E27FC236}">
-                <a16:creationId xmlns:a16="http://schemas.microsoft.com/office/drawing/2014/main" id="{5ECBD6DE-D6EB-4C46-9F72-1225263E905F}"/>
+          <p:cNvPr id="21" name="">
+            <a:extLst xmlns:a="http://schemas.openxmlformats.org/drawingml/2006/main">
+              <a:ext uri="{FF2B5EF4-FFF2-40B4-BE49-F238E27FC236}">
+                <a16:creationId xmlns:a16="http://schemas.microsoft.com/office/drawing/2014/main" id="{253254EE-404D-4E4F-BE6D-B49C82006D1E}"/>
               </a:ext>
             </a:extLst>
           </p:cNvPr>
@@ -1588,7 +1588,7 @@
           <p:cNvPr id="2" name="">
             <a:extLst xmlns:a="http://schemas.openxmlformats.org/drawingml/2006/main">
               <a:ext uri="{FF2B5EF4-FFF2-40B4-BE49-F238E27FC236}">
-                <a16:creationId xmlns:a16="http://schemas.microsoft.com/office/drawing/2014/main" id="{07792DD9-045C-4A9F-B983-F080499F587A}"/>
+                <a16:creationId xmlns:a16="http://schemas.microsoft.com/office/drawing/2014/main" id="{71DBE74A-A493-462C-824F-85D55F6BF1D8}"/>
               </a:ext>
             </a:extLst>
           </p:cNvPr>
@@ -1618,7 +1618,7 @@
           <p:cNvPr id="3" name="">
             <a:extLst xmlns:a="http://schemas.openxmlformats.org/drawingml/2006/main">
               <a:ext uri="{FF2B5EF4-FFF2-40B4-BE49-F238E27FC236}">
-                <a16:creationId xmlns:a16="http://schemas.microsoft.com/office/drawing/2014/main" id="{DB1E4260-6DFA-4C0E-8E91-7A71BE1198AF}"/>
+                <a16:creationId xmlns:a16="http://schemas.microsoft.com/office/drawing/2014/main" id="{DC3419BB-BF9B-40A3-BBD8-EDE42DA87486}"/>
               </a:ext>
             </a:extLst>
           </p:cNvPr>
@@ -1679,7 +1679,7 @@
           <p:cNvPr id="4" name="">
             <a:extLst xmlns:a="http://schemas.openxmlformats.org/drawingml/2006/main">
               <a:ext uri="{FF2B5EF4-FFF2-40B4-BE49-F238E27FC236}">
-                <a16:creationId xmlns:a16="http://schemas.microsoft.com/office/drawing/2014/main" id="{103F6B00-195F-4A6C-B0D9-F1ECBB22D3F3}"/>
+                <a16:creationId xmlns:a16="http://schemas.microsoft.com/office/drawing/2014/main" id="{733F237B-09A7-4E4B-A301-1D13BF717F3F}"/>
               </a:ext>
             </a:extLst>
           </p:cNvPr>
@@ -1794,19 +1794,19 @@
           <p:cNvPr id="5" name="">
             <a:extLst xmlns:a="http://schemas.openxmlformats.org/drawingml/2006/main">
               <a:ext uri="{FF2B5EF4-FFF2-40B4-BE49-F238E27FC236}">
-                <a16:creationId xmlns:a16="http://schemas.microsoft.com/office/drawing/2014/main" id="{CECC2B22-3B5F-4459-B935-D99612A5A39C}"/>
-              </a:ext>
-            </a:extLst>
-          </p:cNvPr>
-          <p:cNvSpPr>
-            <a:spLocks xmlns:a="http://schemas.openxmlformats.org/drawingml/2006/main" noGrp="1"/>
-          </p:cNvSpPr>
-          <p:nvPr/>
-        </p:nvSpPr>
-        <p:spPr>
-          <a:xfrm xmlns:a="http://schemas.openxmlformats.org/drawingml/2006/main">
-            <a:off x="704850" y="3486150"/>
-            <a:ext cx="6858000" cy="762000"/>
+                <a16:creationId xmlns:a16="http://schemas.microsoft.com/office/drawing/2014/main" id="{2203FB05-77EB-4996-940C-9C49CC8A115F}"/>
+              </a:ext>
+            </a:extLst>
+          </p:cNvPr>
+          <p:cNvSpPr>
+            <a:spLocks xmlns:a="http://schemas.openxmlformats.org/drawingml/2006/main" noGrp="1"/>
+          </p:cNvSpPr>
+          <p:nvPr/>
+        </p:nvSpPr>
+        <p:spPr>
+          <a:xfrm xmlns:a="http://schemas.openxmlformats.org/drawingml/2006/main">
+            <a:off x="704850" y="3429000"/>
+            <a:ext cx="6858000" cy="400050"/>
           </a:xfrm>
           <a:prstGeom xmlns:a="http://schemas.openxmlformats.org/drawingml/2006/main" prst="rect">
             <a:avLst/>
@@ -1845,7 +1845,7 @@
                 <a:ea typeface="Arial"/>
                 <a:cs typeface="Arial"/>
               </a:rPr>
-              <a:t>Paper totalVI versus our final FusionVI pipeline on the original totalVI dataset</a:t>
+              <a:t>Paper totalVI versus our final FusionVI pipeline</a:t>
             </a:r>
           </a:p>
         </p:txBody>
@@ -1855,7 +1855,100 @@
           <p:cNvPr id="6" name="">
             <a:extLst xmlns:a="http://schemas.openxmlformats.org/drawingml/2006/main">
               <a:ext uri="{FF2B5EF4-FFF2-40B4-BE49-F238E27FC236}">
-                <a16:creationId xmlns:a16="http://schemas.microsoft.com/office/drawing/2014/main" id="{BE32713A-6057-4490-96D6-D000858109EC}"/>
+                <a16:creationId xmlns:a16="http://schemas.microsoft.com/office/drawing/2014/main" id="{BEC12EC1-1543-4BE5-93BC-051CF957EB2F}"/>
+              </a:ext>
+            </a:extLst>
+          </p:cNvPr>
+          <p:cNvSpPr>
+            <a:spLocks xmlns:a="http://schemas.openxmlformats.org/drawingml/2006/main" noGrp="1"/>
+          </p:cNvSpPr>
+          <p:nvPr/>
+        </p:nvSpPr>
+        <p:spPr>
+          <a:xfrm xmlns:a="http://schemas.openxmlformats.org/drawingml/2006/main">
+            <a:off x="704850" y="3943350"/>
+            <a:ext cx="6743700" cy="457200"/>
+          </a:xfrm>
+          <a:prstGeom xmlns:a="http://schemas.openxmlformats.org/drawingml/2006/main" prst="roundRect">
+            <a:avLst>
+              <a:gd name="adj" fmla="val 25000"/>
+            </a:avLst>
+          </a:prstGeom>
+          <a:solidFill xmlns:a="http://schemas.openxmlformats.org/drawingml/2006/main">
+            <a:srgbClr val="EEF2FF"/>
+          </a:solidFill>
+          <a:ln xmlns:a="http://schemas.openxmlformats.org/drawingml/2006/main" w="0">
+            <a:noFill/>
+          </a:ln>
+        </p:spPr>
+      </p:sp>
+      <p:sp>
+        <p:nvSpPr>
+          <p:cNvPr id="7" name="">
+            <a:extLst xmlns:a="http://schemas.openxmlformats.org/drawingml/2006/main">
+              <a:ext uri="{FF2B5EF4-FFF2-40B4-BE49-F238E27FC236}">
+                <a16:creationId xmlns:a16="http://schemas.microsoft.com/office/drawing/2014/main" id="{864CC86A-8F41-4A08-A38C-D5AF99F4BA67}"/>
+              </a:ext>
+            </a:extLst>
+          </p:cNvPr>
+          <p:cNvSpPr>
+            <a:spLocks xmlns:a="http://schemas.openxmlformats.org/drawingml/2006/main" noGrp="1"/>
+          </p:cNvSpPr>
+          <p:nvPr/>
+        </p:nvSpPr>
+        <p:spPr>
+          <a:xfrm xmlns:a="http://schemas.openxmlformats.org/drawingml/2006/main">
+            <a:off x="876300" y="4038600"/>
+            <a:ext cx="6400800" cy="266700"/>
+          </a:xfrm>
+          <a:prstGeom xmlns:a="http://schemas.openxmlformats.org/drawingml/2006/main" prst="rect">
+            <a:avLst/>
+          </a:prstGeom>
+          <a:noFill xmlns:a="http://schemas.openxmlformats.org/drawingml/2006/main"/>
+          <a:ln xmlns:a="http://schemas.openxmlformats.org/drawingml/2006/main" w="0">
+            <a:noFill/>
+          </a:ln>
+        </p:spPr>
+        <p:txBody>
+          <a:bodyPr xmlns:a="http://schemas.openxmlformats.org/drawingml/2006/main" anchor="ctr">
+            <a:normAutofit fontScale="92147"/>
+          </a:bodyPr>
+          <a:lstStyle xmlns:a="http://schemas.openxmlformats.org/drawingml/2006/main"/>
+          <a:p xmlns:a="http://schemas.openxmlformats.org/drawingml/2006/main">
+            <a:pPr algn="ctr">
+              <a:lnSpc>
+                <a:spcPct val="104000"/>
+              </a:lnSpc>
+              <a:buNone/>
+              <a:defRPr sz="1200" b="1">
+                <a:solidFill>
+                  <a:srgbClr val="4F46E5"/>
+                </a:solidFill>
+                <a:latin typeface="Arial"/>
+                <a:ea typeface="Arial"/>
+                <a:cs typeface="Arial"/>
+              </a:defRPr>
+            </a:pPr>
+            <a:r>
+              <a:rPr sz="1200" b="1">
+                <a:solidFill>
+                  <a:srgbClr val="4F46E5"/>
+                </a:solidFill>
+                <a:latin typeface="Arial"/>
+                <a:ea typeface="Arial"/>
+                <a:cs typeface="Arial"/>
+              </a:rPr>
+              <a:t>Official SLN111 CITE-seq object released with the totalVI paper</a:t>
+            </a:r>
+          </a:p>
+        </p:txBody>
+      </p:sp>
+      <p:sp>
+        <p:nvSpPr>
+          <p:cNvPr id="8" name="">
+            <a:extLst xmlns:a="http://schemas.openxmlformats.org/drawingml/2006/main">
+              <a:ext uri="{FF2B5EF4-FFF2-40B4-BE49-F238E27FC236}">
+                <a16:creationId xmlns:a16="http://schemas.microsoft.com/office/drawing/2014/main" id="{DF90CB2E-C1CE-4029-A288-281B214208CF}"/>
               </a:ext>
             </a:extLst>
           </p:cNvPr>
@@ -1884,10 +1977,10 @@
       </p:sp>
       <p:sp>
         <p:nvSpPr>
-          <p:cNvPr id="7" name="">
-            <a:extLst xmlns:a="http://schemas.openxmlformats.org/drawingml/2006/main">
-              <a:ext uri="{FF2B5EF4-FFF2-40B4-BE49-F238E27FC236}">
-                <a16:creationId xmlns:a16="http://schemas.microsoft.com/office/drawing/2014/main" id="{A60248F6-76B0-4049-B320-E1769E554719}"/>
+          <p:cNvPr id="9" name="">
+            <a:extLst xmlns:a="http://schemas.openxmlformats.org/drawingml/2006/main">
+              <a:ext uri="{FF2B5EF4-FFF2-40B4-BE49-F238E27FC236}">
+                <a16:creationId xmlns:a16="http://schemas.microsoft.com/office/drawing/2014/main" id="{8D6FC12B-1522-49A2-8153-8B9C954BE6FC}"/>
               </a:ext>
             </a:extLst>
           </p:cNvPr>
@@ -1945,10 +2038,10 @@
       </p:sp>
       <p:sp>
         <p:nvSpPr>
-          <p:cNvPr id="8" name="">
-            <a:extLst xmlns:a="http://schemas.openxmlformats.org/drawingml/2006/main">
-              <a:ext uri="{FF2B5EF4-FFF2-40B4-BE49-F238E27FC236}">
-                <a16:creationId xmlns:a16="http://schemas.microsoft.com/office/drawing/2014/main" id="{5B165CFD-8332-442A-9A08-B86A012B5EA4}"/>
+          <p:cNvPr id="10" name="">
+            <a:extLst xmlns:a="http://schemas.openxmlformats.org/drawingml/2006/main">
+              <a:ext uri="{FF2B5EF4-FFF2-40B4-BE49-F238E27FC236}">
+                <a16:creationId xmlns:a16="http://schemas.microsoft.com/office/drawing/2014/main" id="{AE0A6310-62CA-4270-B9B3-3D332E97E1AB}"/>
               </a:ext>
             </a:extLst>
           </p:cNvPr>
@@ -2006,10 +2099,10 @@
       </p:sp>
       <p:sp>
         <p:nvSpPr>
-          <p:cNvPr id="9" name="">
-            <a:extLst xmlns:a="http://schemas.openxmlformats.org/drawingml/2006/main">
-              <a:ext uri="{FF2B5EF4-FFF2-40B4-BE49-F238E27FC236}">
-                <a16:creationId xmlns:a16="http://schemas.microsoft.com/office/drawing/2014/main" id="{729828A1-4F3C-48C2-BE91-8214A59F4727}"/>
+          <p:cNvPr id="11" name="">
+            <a:extLst xmlns:a="http://schemas.openxmlformats.org/drawingml/2006/main">
+              <a:ext uri="{FF2B5EF4-FFF2-40B4-BE49-F238E27FC236}">
+                <a16:creationId xmlns:a16="http://schemas.microsoft.com/office/drawing/2014/main" id="{9F009113-408A-4191-B093-2E1CF59BF607}"/>
               </a:ext>
             </a:extLst>
           </p:cNvPr>
@@ -2038,10 +2131,10 @@
       </p:sp>
       <p:sp>
         <p:nvSpPr>
-          <p:cNvPr id="10" name="">
-            <a:extLst xmlns:a="http://schemas.openxmlformats.org/drawingml/2006/main">
-              <a:ext uri="{FF2B5EF4-FFF2-40B4-BE49-F238E27FC236}">
-                <a16:creationId xmlns:a16="http://schemas.microsoft.com/office/drawing/2014/main" id="{E33A8FD7-784F-46C9-A3F1-126B8E40E230}"/>
+          <p:cNvPr id="12" name="">
+            <a:extLst xmlns:a="http://schemas.openxmlformats.org/drawingml/2006/main">
+              <a:ext uri="{FF2B5EF4-FFF2-40B4-BE49-F238E27FC236}">
+                <a16:creationId xmlns:a16="http://schemas.microsoft.com/office/drawing/2014/main" id="{F82F33C3-59A6-41F0-BB2C-9836D9899B2B}"/>
               </a:ext>
             </a:extLst>
           </p:cNvPr>
@@ -2099,10 +2192,10 @@
       </p:sp>
       <p:sp>
         <p:nvSpPr>
-          <p:cNvPr id="11" name="">
-            <a:extLst xmlns:a="http://schemas.openxmlformats.org/drawingml/2006/main">
-              <a:ext uri="{FF2B5EF4-FFF2-40B4-BE49-F238E27FC236}">
-                <a16:creationId xmlns:a16="http://schemas.microsoft.com/office/drawing/2014/main" id="{2AF4F800-E29D-4616-92C5-66DC8D6A3805}"/>
+          <p:cNvPr id="13" name="">
+            <a:extLst xmlns:a="http://schemas.openxmlformats.org/drawingml/2006/main">
+              <a:ext uri="{FF2B5EF4-FFF2-40B4-BE49-F238E27FC236}">
+                <a16:creationId xmlns:a16="http://schemas.microsoft.com/office/drawing/2014/main" id="{483F9711-78EA-4C69-ACAA-3194ABC80135}"/>
               </a:ext>
             </a:extLst>
           </p:cNvPr>
@@ -2160,10 +2253,10 @@
       </p:sp>
       <p:sp>
         <p:nvSpPr>
-          <p:cNvPr id="12" name="">
-            <a:extLst xmlns:a="http://schemas.openxmlformats.org/drawingml/2006/main">
-              <a:ext uri="{FF2B5EF4-FFF2-40B4-BE49-F238E27FC236}">
-                <a16:creationId xmlns:a16="http://schemas.microsoft.com/office/drawing/2014/main" id="{C2742146-A2B6-4B21-A1B2-AD0FEC66A54C}"/>
+          <p:cNvPr id="14" name="">
+            <a:extLst xmlns:a="http://schemas.openxmlformats.org/drawingml/2006/main">
+              <a:ext uri="{FF2B5EF4-FFF2-40B4-BE49-F238E27FC236}">
+                <a16:creationId xmlns:a16="http://schemas.microsoft.com/office/drawing/2014/main" id="{0EDBCC62-8DDC-4740-A7C6-AC061405ECDD}"/>
               </a:ext>
             </a:extLst>
           </p:cNvPr>
@@ -2192,10 +2285,10 @@
       </p:sp>
       <p:sp>
         <p:nvSpPr>
-          <p:cNvPr id="13" name="">
-            <a:extLst xmlns:a="http://schemas.openxmlformats.org/drawingml/2006/main">
-              <a:ext uri="{FF2B5EF4-FFF2-40B4-BE49-F238E27FC236}">
-                <a16:creationId xmlns:a16="http://schemas.microsoft.com/office/drawing/2014/main" id="{7050A449-962F-42BA-80AD-FE9D70FFCCDD}"/>
+          <p:cNvPr id="15" name="">
+            <a:extLst xmlns:a="http://schemas.openxmlformats.org/drawingml/2006/main">
+              <a:ext uri="{FF2B5EF4-FFF2-40B4-BE49-F238E27FC236}">
+                <a16:creationId xmlns:a16="http://schemas.microsoft.com/office/drawing/2014/main" id="{4627B23F-8987-45B6-98A4-24CD6428250D}"/>
               </a:ext>
             </a:extLst>
           </p:cNvPr>
@@ -2253,10 +2346,10 @@
       </p:sp>
       <p:sp>
         <p:nvSpPr>
-          <p:cNvPr id="14" name="">
-            <a:extLst xmlns:a="http://schemas.openxmlformats.org/drawingml/2006/main">
-              <a:ext uri="{FF2B5EF4-FFF2-40B4-BE49-F238E27FC236}">
-                <a16:creationId xmlns:a16="http://schemas.microsoft.com/office/drawing/2014/main" id="{F5F88A39-2D35-4FDA-A24A-37DA1DF8F63E}"/>
+          <p:cNvPr id="16" name="">
+            <a:extLst xmlns:a="http://schemas.openxmlformats.org/drawingml/2006/main">
+              <a:ext uri="{FF2B5EF4-FFF2-40B4-BE49-F238E27FC236}">
+                <a16:creationId xmlns:a16="http://schemas.microsoft.com/office/drawing/2014/main" id="{118B1A07-A3FA-4DC2-8595-D08AF188596A}"/>
               </a:ext>
             </a:extLst>
           </p:cNvPr>
@@ -2314,10 +2407,10 @@
       </p:sp>
       <p:sp>
         <p:nvSpPr>
-          <p:cNvPr id="15" name="">
-            <a:extLst xmlns:a="http://schemas.openxmlformats.org/drawingml/2006/main">
-              <a:ext uri="{FF2B5EF4-FFF2-40B4-BE49-F238E27FC236}">
-                <a16:creationId xmlns:a16="http://schemas.microsoft.com/office/drawing/2014/main" id="{0E9D10EE-F3A3-4923-BF41-E07007861E04}"/>
+          <p:cNvPr id="17" name="">
+            <a:extLst xmlns:a="http://schemas.openxmlformats.org/drawingml/2006/main">
+              <a:ext uri="{FF2B5EF4-FFF2-40B4-BE49-F238E27FC236}">
+                <a16:creationId xmlns:a16="http://schemas.microsoft.com/office/drawing/2014/main" id="{27C5F2C8-418E-44EE-90FE-0E2122EEB9EF}"/>
               </a:ext>
             </a:extLst>
           </p:cNvPr>
@@ -2375,10 +2468,10 @@
       </p:sp>
       <p:sp>
         <p:nvSpPr>
-          <p:cNvPr id="16" name="">
-            <a:extLst xmlns:a="http://schemas.openxmlformats.org/drawingml/2006/main">
-              <a:ext uri="{FF2B5EF4-FFF2-40B4-BE49-F238E27FC236}">
-                <a16:creationId xmlns:a16="http://schemas.microsoft.com/office/drawing/2014/main" id="{2D020F1B-1F0D-4C98-A9D8-FC6C4A35D986}"/>
+          <p:cNvPr id="18" name="">
+            <a:extLst xmlns:a="http://schemas.openxmlformats.org/drawingml/2006/main">
+              <a:ext uri="{FF2B5EF4-FFF2-40B4-BE49-F238E27FC236}">
+                <a16:creationId xmlns:a16="http://schemas.microsoft.com/office/drawing/2014/main" id="{F41FA2A6-F34B-449E-A6FA-94EA5DE051AD}"/>
               </a:ext>
             </a:extLst>
           </p:cNvPr>
@@ -2436,10 +2529,10 @@
       </p:sp>
       <p:sp>
         <p:nvSpPr>
-          <p:cNvPr id="17" name="">
-            <a:extLst xmlns:a="http://schemas.openxmlformats.org/drawingml/2006/main">
-              <a:ext uri="{FF2B5EF4-FFF2-40B4-BE49-F238E27FC236}">
-                <a16:creationId xmlns:a16="http://schemas.microsoft.com/office/drawing/2014/main" id="{2383783B-8465-4D8F-9BD7-6D93EFC16FB1}"/>
+          <p:cNvPr id="19" name="">
+            <a:extLst xmlns:a="http://schemas.openxmlformats.org/drawingml/2006/main">
+              <a:ext uri="{FF2B5EF4-FFF2-40B4-BE49-F238E27FC236}">
+                <a16:creationId xmlns:a16="http://schemas.microsoft.com/office/drawing/2014/main" id="{530E6E4F-0346-43F9-A15C-5754A2927D4A}"/>
               </a:ext>
             </a:extLst>
           </p:cNvPr>
@@ -2497,10 +2590,10 @@
       </p:sp>
       <p:sp>
         <p:nvSpPr>
-          <p:cNvPr id="18" name="">
-            <a:extLst xmlns:a="http://schemas.openxmlformats.org/drawingml/2006/main">
-              <a:ext uri="{FF2B5EF4-FFF2-40B4-BE49-F238E27FC236}">
-                <a16:creationId xmlns:a16="http://schemas.microsoft.com/office/drawing/2014/main" id="{AEC4D4EC-F55D-4471-99DD-F1FFE57D05E3}"/>
+          <p:cNvPr id="20" name="">
+            <a:extLst xmlns:a="http://schemas.openxmlformats.org/drawingml/2006/main">
+              <a:ext uri="{FF2B5EF4-FFF2-40B4-BE49-F238E27FC236}">
+                <a16:creationId xmlns:a16="http://schemas.microsoft.com/office/drawing/2014/main" id="{8793C35B-DAFB-4510-915A-0371A94A3419}"/>
               </a:ext>
             </a:extLst>
           </p:cNvPr>
@@ -2559,7 +2652,7 @@
     </p:spTree>
     <p:extLst>
       <p:ext uri="{BB962C8B-B14F-4D97-AF65-F5344CB8AC3E}">
-        <p14:creationId xmlns:p14="http://schemas.microsoft.com/office/powerpoint/2010/main" val="627622741"/>
+        <p14:creationId xmlns:p14="http://schemas.microsoft.com/office/powerpoint/2010/main" val="711474712"/>
       </p:ext>
     </p:extLst>
   </p:cSld>
@@ -2590,7 +2683,7 @@
           <p:cNvPr id="32" name="">
             <a:extLst xmlns:a="http://schemas.openxmlformats.org/drawingml/2006/main">
               <a:ext uri="{FF2B5EF4-FFF2-40B4-BE49-F238E27FC236}">
-                <a16:creationId xmlns:a16="http://schemas.microsoft.com/office/drawing/2014/main" id="{236923D3-C53F-4CF1-B2A7-F6BA2774A5F1}"/>
+                <a16:creationId xmlns:a16="http://schemas.microsoft.com/office/drawing/2014/main" id="{C7B9D5E9-3087-442B-8DD2-680F091EEBD5}"/>
               </a:ext>
             </a:extLst>
           </p:cNvPr>
@@ -2651,7 +2744,7 @@
           <p:cNvPr id="2" name="">
             <a:extLst xmlns:a="http://schemas.openxmlformats.org/drawingml/2006/main">
               <a:ext uri="{FF2B5EF4-FFF2-40B4-BE49-F238E27FC236}">
-                <a16:creationId xmlns:a16="http://schemas.microsoft.com/office/drawing/2014/main" id="{CA6CB5CE-F538-4CF7-A020-4427B0FFB523}"/>
+                <a16:creationId xmlns:a16="http://schemas.microsoft.com/office/drawing/2014/main" id="{A83B599E-C02C-44D3-97FC-2FF854F8122C}"/>
               </a:ext>
             </a:extLst>
           </p:cNvPr>
@@ -2712,7 +2805,7 @@
           <p:cNvPr id="3" name="">
             <a:extLst xmlns:a="http://schemas.openxmlformats.org/drawingml/2006/main">
               <a:ext uri="{FF2B5EF4-FFF2-40B4-BE49-F238E27FC236}">
-                <a16:creationId xmlns:a16="http://schemas.microsoft.com/office/drawing/2014/main" id="{05F21C3D-B83C-4D93-9F5F-65F6B7567381}"/>
+                <a16:creationId xmlns:a16="http://schemas.microsoft.com/office/drawing/2014/main" id="{5636433D-50BE-4E18-9C36-00CE86186BC6}"/>
               </a:ext>
             </a:extLst>
           </p:cNvPr>
@@ -2742,7 +2835,7 @@
           <p:cNvPr id="4" name="">
             <a:extLst xmlns:a="http://schemas.openxmlformats.org/drawingml/2006/main">
               <a:ext uri="{FF2B5EF4-FFF2-40B4-BE49-F238E27FC236}">
-                <a16:creationId xmlns:a16="http://schemas.microsoft.com/office/drawing/2014/main" id="{E746A317-E197-4263-A986-FCF160F658D2}"/>
+                <a16:creationId xmlns:a16="http://schemas.microsoft.com/office/drawing/2014/main" id="{1AA4D4B0-D344-4462-8FBD-8071B328F3C0}"/>
               </a:ext>
             </a:extLst>
           </p:cNvPr>
@@ -2803,7 +2896,7 @@
           <p:cNvPr id="5" name="">
             <a:extLst xmlns:a="http://schemas.openxmlformats.org/drawingml/2006/main">
               <a:ext uri="{FF2B5EF4-FFF2-40B4-BE49-F238E27FC236}">
-                <a16:creationId xmlns:a16="http://schemas.microsoft.com/office/drawing/2014/main" id="{60C376FB-08A7-486F-8FFA-F172585C75CA}"/>
+                <a16:creationId xmlns:a16="http://schemas.microsoft.com/office/drawing/2014/main" id="{3BC52A35-AF76-4CF3-B7EB-F2368CDDD6B7}"/>
               </a:ext>
             </a:extLst>
           </p:cNvPr>
@@ -2864,7 +2957,7 @@
           <p:cNvPr id="6" name="">
             <a:extLst xmlns:a="http://schemas.openxmlformats.org/drawingml/2006/main">
               <a:ext uri="{FF2B5EF4-FFF2-40B4-BE49-F238E27FC236}">
-                <a16:creationId xmlns:a16="http://schemas.microsoft.com/office/drawing/2014/main" id="{1DD62638-81BF-4358-B8D4-3F1DDA5689CF}"/>
+                <a16:creationId xmlns:a16="http://schemas.microsoft.com/office/drawing/2014/main" id="{D27D16C2-5244-4BBB-88BB-BBF0ED54EC31}"/>
               </a:ext>
             </a:extLst>
           </p:cNvPr>
@@ -2896,7 +2989,7 @@
           <p:cNvPr id="7" name="">
             <a:extLst xmlns:a="http://schemas.openxmlformats.org/drawingml/2006/main">
               <a:ext uri="{FF2B5EF4-FFF2-40B4-BE49-F238E27FC236}">
-                <a16:creationId xmlns:a16="http://schemas.microsoft.com/office/drawing/2014/main" id="{23B2E282-4D04-4642-A47F-FD22AC54E7E1}"/>
+                <a16:creationId xmlns:a16="http://schemas.microsoft.com/office/drawing/2014/main" id="{5CA8DCF1-6D93-43A7-8FDB-95DF08198F6C}"/>
               </a:ext>
             </a:extLst>
           </p:cNvPr>
@@ -2957,7 +3050,7 @@
           <p:cNvPr id="8" name="">
             <a:extLst xmlns:a="http://schemas.openxmlformats.org/drawingml/2006/main">
               <a:ext uri="{FF2B5EF4-FFF2-40B4-BE49-F238E27FC236}">
-                <a16:creationId xmlns:a16="http://schemas.microsoft.com/office/drawing/2014/main" id="{B1C72F4B-11AE-4E0E-ADB5-A32618046059}"/>
+                <a16:creationId xmlns:a16="http://schemas.microsoft.com/office/drawing/2014/main" id="{A59FB779-121B-4CBE-9BAF-DDA9E437BF6F}"/>
               </a:ext>
             </a:extLst>
           </p:cNvPr>
@@ -3018,7 +3111,7 @@
           <p:cNvPr id="9" name="">
             <a:extLst xmlns:a="http://schemas.openxmlformats.org/drawingml/2006/main">
               <a:ext uri="{FF2B5EF4-FFF2-40B4-BE49-F238E27FC236}">
-                <a16:creationId xmlns:a16="http://schemas.microsoft.com/office/drawing/2014/main" id="{276A9EA2-BE60-4313-91B3-AF8B2D686222}"/>
+                <a16:creationId xmlns:a16="http://schemas.microsoft.com/office/drawing/2014/main" id="{2EFAD5DA-F69A-428B-99FC-9ABA36F9F036}"/>
               </a:ext>
             </a:extLst>
           </p:cNvPr>
@@ -3079,7 +3172,7 @@
           <p:cNvPr id="10" name="">
             <a:extLst xmlns:a="http://schemas.openxmlformats.org/drawingml/2006/main">
               <a:ext uri="{FF2B5EF4-FFF2-40B4-BE49-F238E27FC236}">
-                <a16:creationId xmlns:a16="http://schemas.microsoft.com/office/drawing/2014/main" id="{136EDD74-A327-4382-AE7D-9E4208287AE8}"/>
+                <a16:creationId xmlns:a16="http://schemas.microsoft.com/office/drawing/2014/main" id="{DD1F6C92-6C1E-433A-AA6C-F94CF651D157}"/>
               </a:ext>
             </a:extLst>
           </p:cNvPr>
@@ -3111,7 +3204,7 @@
           <p:cNvPr id="11" name="">
             <a:extLst xmlns:a="http://schemas.openxmlformats.org/drawingml/2006/main">
               <a:ext uri="{FF2B5EF4-FFF2-40B4-BE49-F238E27FC236}">
-                <a16:creationId xmlns:a16="http://schemas.microsoft.com/office/drawing/2014/main" id="{6B257D48-32CE-4241-A4D7-06FD9810B230}"/>
+                <a16:creationId xmlns:a16="http://schemas.microsoft.com/office/drawing/2014/main" id="{4A8AC3AB-76F2-419B-97D6-2E1DBB8B77F5}"/>
               </a:ext>
             </a:extLst>
           </p:cNvPr>
@@ -3172,7 +3265,7 @@
           <p:cNvPr id="12" name="">
             <a:extLst xmlns:a="http://schemas.openxmlformats.org/drawingml/2006/main">
               <a:ext uri="{FF2B5EF4-FFF2-40B4-BE49-F238E27FC236}">
-                <a16:creationId xmlns:a16="http://schemas.microsoft.com/office/drawing/2014/main" id="{D91A45FF-C880-4222-A802-AB0D15AC9247}"/>
+                <a16:creationId xmlns:a16="http://schemas.microsoft.com/office/drawing/2014/main" id="{F72ED17F-B9D2-425A-BCF0-3DDE02A57580}"/>
               </a:ext>
             </a:extLst>
           </p:cNvPr>
@@ -3204,7 +3297,7 @@
           <p:cNvPr id="13" name="">
             <a:extLst xmlns:a="http://schemas.openxmlformats.org/drawingml/2006/main">
               <a:ext uri="{FF2B5EF4-FFF2-40B4-BE49-F238E27FC236}">
-                <a16:creationId xmlns:a16="http://schemas.microsoft.com/office/drawing/2014/main" id="{B59192D5-E38A-43CA-87FB-E6E8212BA4A3}"/>
+                <a16:creationId xmlns:a16="http://schemas.microsoft.com/office/drawing/2014/main" id="{BFCCDD82-5BA8-4E55-817F-C8CB3D93FC4B}"/>
               </a:ext>
             </a:extLst>
           </p:cNvPr>
@@ -3265,7 +3358,7 @@
           <p:cNvPr id="14" name="">
             <a:extLst xmlns:a="http://schemas.openxmlformats.org/drawingml/2006/main">
               <a:ext uri="{FF2B5EF4-FFF2-40B4-BE49-F238E27FC236}">
-                <a16:creationId xmlns:a16="http://schemas.microsoft.com/office/drawing/2014/main" id="{E15FEA3E-59F6-4F51-8359-4A0A395D795A}"/>
+                <a16:creationId xmlns:a16="http://schemas.microsoft.com/office/drawing/2014/main" id="{56DDA92F-F07E-4856-B705-43654F0EEF5E}"/>
               </a:ext>
             </a:extLst>
           </p:cNvPr>
@@ -3326,7 +3419,7 @@
           <p:cNvPr id="15" name="">
             <a:extLst xmlns:a="http://schemas.openxmlformats.org/drawingml/2006/main">
               <a:ext uri="{FF2B5EF4-FFF2-40B4-BE49-F238E27FC236}">
-                <a16:creationId xmlns:a16="http://schemas.microsoft.com/office/drawing/2014/main" id="{9F0551F7-508D-410F-BAE2-00C4E2735AF7}"/>
+                <a16:creationId xmlns:a16="http://schemas.microsoft.com/office/drawing/2014/main" id="{24685452-D5E4-4F36-9250-CBB1D8B339EA}"/>
               </a:ext>
             </a:extLst>
           </p:cNvPr>
@@ -3387,7 +3480,7 @@
           <p:cNvPr id="16" name="">
             <a:extLst xmlns:a="http://schemas.openxmlformats.org/drawingml/2006/main">
               <a:ext uri="{FF2B5EF4-FFF2-40B4-BE49-F238E27FC236}">
-                <a16:creationId xmlns:a16="http://schemas.microsoft.com/office/drawing/2014/main" id="{45876454-2FAE-4DE9-87BD-C4CA43863971}"/>
+                <a16:creationId xmlns:a16="http://schemas.microsoft.com/office/drawing/2014/main" id="{88D301A9-3214-4605-8B7A-1F2B67846F6A}"/>
               </a:ext>
             </a:extLst>
           </p:cNvPr>
@@ -3419,7 +3512,7 @@
           <p:cNvPr id="17" name="">
             <a:extLst xmlns:a="http://schemas.openxmlformats.org/drawingml/2006/main">
               <a:ext uri="{FF2B5EF4-FFF2-40B4-BE49-F238E27FC236}">
-                <a16:creationId xmlns:a16="http://schemas.microsoft.com/office/drawing/2014/main" id="{A3D3FF4F-021C-4CAD-9BEB-4F4EC454E00A}"/>
+                <a16:creationId xmlns:a16="http://schemas.microsoft.com/office/drawing/2014/main" id="{21E5414E-E368-4FE4-8B7D-F1407B0EDAED}"/>
               </a:ext>
             </a:extLst>
           </p:cNvPr>
@@ -3480,7 +3573,7 @@
           <p:cNvPr id="18" name="">
             <a:extLst xmlns:a="http://schemas.openxmlformats.org/drawingml/2006/main">
               <a:ext uri="{FF2B5EF4-FFF2-40B4-BE49-F238E27FC236}">
-                <a16:creationId xmlns:a16="http://schemas.microsoft.com/office/drawing/2014/main" id="{8A297D4D-EC29-4981-A600-E8E6B860587A}"/>
+                <a16:creationId xmlns:a16="http://schemas.microsoft.com/office/drawing/2014/main" id="{0EAAB1AC-8C99-40FC-AE9D-7C93B1AE37EA}"/>
               </a:ext>
             </a:extLst>
           </p:cNvPr>
@@ -3512,7 +3605,7 @@
           <p:cNvPr id="19" name="">
             <a:extLst xmlns:a="http://schemas.openxmlformats.org/drawingml/2006/main">
               <a:ext uri="{FF2B5EF4-FFF2-40B4-BE49-F238E27FC236}">
-                <a16:creationId xmlns:a16="http://schemas.microsoft.com/office/drawing/2014/main" id="{F7F90051-4430-48BD-874F-5B88CBF0316D}"/>
+                <a16:creationId xmlns:a16="http://schemas.microsoft.com/office/drawing/2014/main" id="{52DDBC2C-4814-4A1D-A7E4-A3B5D8DFCF85}"/>
               </a:ext>
             </a:extLst>
           </p:cNvPr>
@@ -3573,7 +3666,7 @@
           <p:cNvPr id="20" name="">
             <a:extLst xmlns:a="http://schemas.openxmlformats.org/drawingml/2006/main">
               <a:ext uri="{FF2B5EF4-FFF2-40B4-BE49-F238E27FC236}">
-                <a16:creationId xmlns:a16="http://schemas.microsoft.com/office/drawing/2014/main" id="{CF3F7BE9-31F3-4F0E-9822-CB8B8CE3D7FF}"/>
+                <a16:creationId xmlns:a16="http://schemas.microsoft.com/office/drawing/2014/main" id="{0E74148F-DF0B-4A90-A42A-F68DCBC59F9D}"/>
               </a:ext>
             </a:extLst>
           </p:cNvPr>
@@ -3634,7 +3727,7 @@
           <p:cNvPr id="21" name="">
             <a:extLst xmlns:a="http://schemas.openxmlformats.org/drawingml/2006/main">
               <a:ext uri="{FF2B5EF4-FFF2-40B4-BE49-F238E27FC236}">
-                <a16:creationId xmlns:a16="http://schemas.microsoft.com/office/drawing/2014/main" id="{56E01B50-F789-4DF8-AF01-0645DE2B0248}"/>
+                <a16:creationId xmlns:a16="http://schemas.microsoft.com/office/drawing/2014/main" id="{2AEAA0DB-AC6C-48C6-9BE4-3C2B9B0B02D8}"/>
               </a:ext>
             </a:extLst>
           </p:cNvPr>
@@ -3695,7 +3788,7 @@
           <p:cNvPr id="22" name="">
             <a:extLst xmlns:a="http://schemas.openxmlformats.org/drawingml/2006/main">
               <a:ext uri="{FF2B5EF4-FFF2-40B4-BE49-F238E27FC236}">
-                <a16:creationId xmlns:a16="http://schemas.microsoft.com/office/drawing/2014/main" id="{8299087C-C726-4884-A759-598DB9D3C3AA}"/>
+                <a16:creationId xmlns:a16="http://schemas.microsoft.com/office/drawing/2014/main" id="{6855A5AC-B61D-4E1A-B7D7-BDFD47FDED5A}"/>
               </a:ext>
             </a:extLst>
           </p:cNvPr>
@@ -3727,7 +3820,7 @@
           <p:cNvPr id="23" name="">
             <a:extLst xmlns:a="http://schemas.openxmlformats.org/drawingml/2006/main">
               <a:ext uri="{FF2B5EF4-FFF2-40B4-BE49-F238E27FC236}">
-                <a16:creationId xmlns:a16="http://schemas.microsoft.com/office/drawing/2014/main" id="{3CAC57CB-FDD2-4A7F-A95F-5C2DEA9AEC16}"/>
+                <a16:creationId xmlns:a16="http://schemas.microsoft.com/office/drawing/2014/main" id="{046218E1-FD64-4BCD-A39B-948411014D59}"/>
               </a:ext>
             </a:extLst>
           </p:cNvPr>
@@ -3788,7 +3881,7 @@
           <p:cNvPr id="24" name="">
             <a:extLst xmlns:a="http://schemas.openxmlformats.org/drawingml/2006/main">
               <a:ext uri="{FF2B5EF4-FFF2-40B4-BE49-F238E27FC236}">
-                <a16:creationId xmlns:a16="http://schemas.microsoft.com/office/drawing/2014/main" id="{78DD82CD-EEDC-402A-A94D-D60D86C499F9}"/>
+                <a16:creationId xmlns:a16="http://schemas.microsoft.com/office/drawing/2014/main" id="{EE58221D-08A7-4D45-8E17-C11C017E469A}"/>
               </a:ext>
             </a:extLst>
           </p:cNvPr>
@@ -3820,7 +3913,7 @@
           <p:cNvPr id="25" name="">
             <a:extLst xmlns:a="http://schemas.openxmlformats.org/drawingml/2006/main">
               <a:ext uri="{FF2B5EF4-FFF2-40B4-BE49-F238E27FC236}">
-                <a16:creationId xmlns:a16="http://schemas.microsoft.com/office/drawing/2014/main" id="{FE2AAF88-CE7D-45C3-B42E-4B9A9A98FD59}"/>
+                <a16:creationId xmlns:a16="http://schemas.microsoft.com/office/drawing/2014/main" id="{F3ADFA2B-5312-468A-993D-DA54FC318080}"/>
               </a:ext>
             </a:extLst>
           </p:cNvPr>
@@ -3881,7 +3974,7 @@
           <p:cNvPr id="26" name="">
             <a:extLst xmlns:a="http://schemas.openxmlformats.org/drawingml/2006/main">
               <a:ext uri="{FF2B5EF4-FFF2-40B4-BE49-F238E27FC236}">
-                <a16:creationId xmlns:a16="http://schemas.microsoft.com/office/drawing/2014/main" id="{FD89DF50-66CD-459A-85F3-27CE42A346BA}"/>
+                <a16:creationId xmlns:a16="http://schemas.microsoft.com/office/drawing/2014/main" id="{F77E4F51-BC58-44D3-BC61-22C632A0E8A5}"/>
               </a:ext>
             </a:extLst>
           </p:cNvPr>
@@ -3942,7 +4035,7 @@
           <p:cNvPr id="27" name="">
             <a:extLst xmlns:a="http://schemas.openxmlformats.org/drawingml/2006/main">
               <a:ext uri="{FF2B5EF4-FFF2-40B4-BE49-F238E27FC236}">
-                <a16:creationId xmlns:a16="http://schemas.microsoft.com/office/drawing/2014/main" id="{F94CC119-989E-413E-B96F-5C583548DC96}"/>
+                <a16:creationId xmlns:a16="http://schemas.microsoft.com/office/drawing/2014/main" id="{011543BD-A92D-4055-AD59-2E84139241EF}"/>
               </a:ext>
             </a:extLst>
           </p:cNvPr>
@@ -4003,7 +4096,7 @@
           <p:cNvPr id="28" name="">
             <a:extLst xmlns:a="http://schemas.openxmlformats.org/drawingml/2006/main">
               <a:ext uri="{FF2B5EF4-FFF2-40B4-BE49-F238E27FC236}">
-                <a16:creationId xmlns:a16="http://schemas.microsoft.com/office/drawing/2014/main" id="{C343817A-6C46-4826-A0E2-FBF51CFBEFAE}"/>
+                <a16:creationId xmlns:a16="http://schemas.microsoft.com/office/drawing/2014/main" id="{4B6B3134-527F-4F41-BBA5-9F356BF0C0E9}"/>
               </a:ext>
             </a:extLst>
           </p:cNvPr>
@@ -4035,7 +4128,7 @@
           <p:cNvPr id="29" name="">
             <a:extLst xmlns:a="http://schemas.openxmlformats.org/drawingml/2006/main">
               <a:ext uri="{FF2B5EF4-FFF2-40B4-BE49-F238E27FC236}">
-                <a16:creationId xmlns:a16="http://schemas.microsoft.com/office/drawing/2014/main" id="{8540C910-DA4E-4BEC-8097-B2E32DAA5DF9}"/>
+                <a16:creationId xmlns:a16="http://schemas.microsoft.com/office/drawing/2014/main" id="{C6BAB793-FBD1-4517-8D96-87DB0FA89500}"/>
               </a:ext>
             </a:extLst>
           </p:cNvPr>
@@ -4096,7 +4189,7 @@
           <p:cNvPr id="30" name="">
             <a:extLst xmlns:a="http://schemas.openxmlformats.org/drawingml/2006/main">
               <a:ext uri="{FF2B5EF4-FFF2-40B4-BE49-F238E27FC236}">
-                <a16:creationId xmlns:a16="http://schemas.microsoft.com/office/drawing/2014/main" id="{245A0695-EB56-4045-AD09-275D387B43EE}"/>
+                <a16:creationId xmlns:a16="http://schemas.microsoft.com/office/drawing/2014/main" id="{51E12772-64D5-4956-B332-6264746DF58F}"/>
               </a:ext>
             </a:extLst>
           </p:cNvPr>
@@ -4130,7 +4223,7 @@
           <p:cNvPr id="31" name="">
             <a:extLst xmlns:a="http://schemas.openxmlformats.org/drawingml/2006/main">
               <a:ext uri="{FF2B5EF4-FFF2-40B4-BE49-F238E27FC236}">
-                <a16:creationId xmlns:a16="http://schemas.microsoft.com/office/drawing/2014/main" id="{CA295339-05C3-48F4-92ED-4A1430E51E7D}"/>
+                <a16:creationId xmlns:a16="http://schemas.microsoft.com/office/drawing/2014/main" id="{745C8BFD-317C-4663-92C4-AEB5F86BB9AC}"/>
               </a:ext>
             </a:extLst>
           </p:cNvPr>
@@ -4189,7 +4282,7 @@
     </p:spTree>
     <p:extLst>
       <p:ext uri="{BB962C8B-B14F-4D97-AF65-F5344CB8AC3E}">
-        <p14:creationId xmlns:p14="http://schemas.microsoft.com/office/powerpoint/2010/main" val="1792845117"/>
+        <p14:creationId xmlns:p14="http://schemas.microsoft.com/office/powerpoint/2010/main" val="897124473"/>
       </p:ext>
     </p:extLst>
   </p:cSld>
@@ -4220,7 +4313,7 @@
           <p:cNvPr id="32" name="">
             <a:extLst xmlns:a="http://schemas.openxmlformats.org/drawingml/2006/main">
               <a:ext uri="{FF2B5EF4-FFF2-40B4-BE49-F238E27FC236}">
-                <a16:creationId xmlns:a16="http://schemas.microsoft.com/office/drawing/2014/main" id="{E4781EFB-1160-4592-A865-50E6E10F8991}"/>
+                <a16:creationId xmlns:a16="http://schemas.microsoft.com/office/drawing/2014/main" id="{D278F18B-6DFF-43CA-A192-7E03A8CEF335}"/>
               </a:ext>
             </a:extLst>
           </p:cNvPr>
@@ -4281,7 +4374,7 @@
           <p:cNvPr id="2" name="">
             <a:extLst xmlns:a="http://schemas.openxmlformats.org/drawingml/2006/main">
               <a:ext uri="{FF2B5EF4-FFF2-40B4-BE49-F238E27FC236}">
-                <a16:creationId xmlns:a16="http://schemas.microsoft.com/office/drawing/2014/main" id="{0E533A76-7C42-4272-863B-B1A2B211A9FB}"/>
+                <a16:creationId xmlns:a16="http://schemas.microsoft.com/office/drawing/2014/main" id="{71D807F4-2D2A-4956-97BA-BFD0972BBB79}"/>
               </a:ext>
             </a:extLst>
           </p:cNvPr>
@@ -4342,7 +4435,7 @@
           <p:cNvPr id="3" name="">
             <a:extLst xmlns:a="http://schemas.openxmlformats.org/drawingml/2006/main">
               <a:ext uri="{FF2B5EF4-FFF2-40B4-BE49-F238E27FC236}">
-                <a16:creationId xmlns:a16="http://schemas.microsoft.com/office/drawing/2014/main" id="{17BF149A-8ADA-446B-AB96-6B4FBB13C4C8}"/>
+                <a16:creationId xmlns:a16="http://schemas.microsoft.com/office/drawing/2014/main" id="{16B77C88-0495-4924-8F35-86A4024CD6BF}"/>
               </a:ext>
             </a:extLst>
           </p:cNvPr>
@@ -4372,7 +4465,7 @@
           <p:cNvPr id="4" name="">
             <a:extLst xmlns:a="http://schemas.openxmlformats.org/drawingml/2006/main">
               <a:ext uri="{FF2B5EF4-FFF2-40B4-BE49-F238E27FC236}">
-                <a16:creationId xmlns:a16="http://schemas.microsoft.com/office/drawing/2014/main" id="{E7A64DB3-EE7E-4B9A-975C-CD6DE73076AC}"/>
+                <a16:creationId xmlns:a16="http://schemas.microsoft.com/office/drawing/2014/main" id="{155A671C-0FFB-4FAD-92EF-187F722631EE}"/>
               </a:ext>
             </a:extLst>
           </p:cNvPr>
@@ -4433,7 +4526,7 @@
           <p:cNvPr id="5" name="">
             <a:extLst xmlns:a="http://schemas.openxmlformats.org/drawingml/2006/main">
               <a:ext uri="{FF2B5EF4-FFF2-40B4-BE49-F238E27FC236}">
-                <a16:creationId xmlns:a16="http://schemas.microsoft.com/office/drawing/2014/main" id="{43C3AE0A-D00B-4D3C-9239-F258519E84F2}"/>
+                <a16:creationId xmlns:a16="http://schemas.microsoft.com/office/drawing/2014/main" id="{628A53B9-B997-489C-B7BD-5C37ADEF8CD2}"/>
               </a:ext>
             </a:extLst>
           </p:cNvPr>
@@ -4465,7 +4558,7 @@
           <p:cNvPr id="6" name="">
             <a:extLst xmlns:a="http://schemas.openxmlformats.org/drawingml/2006/main">
               <a:ext uri="{FF2B5EF4-FFF2-40B4-BE49-F238E27FC236}">
-                <a16:creationId xmlns:a16="http://schemas.microsoft.com/office/drawing/2014/main" id="{0ECB7EF1-C799-472D-8337-188B2249E7B4}"/>
+                <a16:creationId xmlns:a16="http://schemas.microsoft.com/office/drawing/2014/main" id="{B5D6C0C7-192E-4106-9CAC-CC7F911022A7}"/>
               </a:ext>
             </a:extLst>
           </p:cNvPr>
@@ -4526,7 +4619,7 @@
           <p:cNvPr id="7" name="">
             <a:extLst xmlns:a="http://schemas.openxmlformats.org/drawingml/2006/main">
               <a:ext uri="{FF2B5EF4-FFF2-40B4-BE49-F238E27FC236}">
-                <a16:creationId xmlns:a16="http://schemas.microsoft.com/office/drawing/2014/main" id="{A7E508A7-6DA3-48C0-9253-455D610F7EFD}"/>
+                <a16:creationId xmlns:a16="http://schemas.microsoft.com/office/drawing/2014/main" id="{20E1A12C-BE89-48A0-AAB2-702A55365930}"/>
               </a:ext>
             </a:extLst>
           </p:cNvPr>
@@ -4587,7 +4680,7 @@
           <p:cNvPr id="8" name="">
             <a:extLst xmlns:a="http://schemas.openxmlformats.org/drawingml/2006/main">
               <a:ext uri="{FF2B5EF4-FFF2-40B4-BE49-F238E27FC236}">
-                <a16:creationId xmlns:a16="http://schemas.microsoft.com/office/drawing/2014/main" id="{85D6EC04-A533-49CC-BF22-2F1FC0D52B27}"/>
+                <a16:creationId xmlns:a16="http://schemas.microsoft.com/office/drawing/2014/main" id="{A918FCD4-DA33-463E-9B0C-65E82FD6B597}"/>
               </a:ext>
             </a:extLst>
           </p:cNvPr>
@@ -4619,7 +4712,7 @@
           <p:cNvPr id="9" name="">
             <a:extLst xmlns:a="http://schemas.openxmlformats.org/drawingml/2006/main">
               <a:ext uri="{FF2B5EF4-FFF2-40B4-BE49-F238E27FC236}">
-                <a16:creationId xmlns:a16="http://schemas.microsoft.com/office/drawing/2014/main" id="{50525201-E9A1-4717-B40F-CFB608A06EC8}"/>
+                <a16:creationId xmlns:a16="http://schemas.microsoft.com/office/drawing/2014/main" id="{9F681688-B834-44B8-95F7-1E95BD22B2BC}"/>
               </a:ext>
             </a:extLst>
           </p:cNvPr>
@@ -4680,7 +4773,7 @@
           <p:cNvPr id="10" name="">
             <a:extLst xmlns:a="http://schemas.openxmlformats.org/drawingml/2006/main">
               <a:ext uri="{FF2B5EF4-FFF2-40B4-BE49-F238E27FC236}">
-                <a16:creationId xmlns:a16="http://schemas.microsoft.com/office/drawing/2014/main" id="{4F3CDFAD-288D-4CE1-AE2B-65E801898E70}"/>
+                <a16:creationId xmlns:a16="http://schemas.microsoft.com/office/drawing/2014/main" id="{9A42F196-4210-4FF1-AC1C-7DAABCEBE6D3}"/>
               </a:ext>
             </a:extLst>
           </p:cNvPr>
@@ -4741,7 +4834,7 @@
           <p:cNvPr id="11" name="">
             <a:extLst xmlns:a="http://schemas.openxmlformats.org/drawingml/2006/main">
               <a:ext uri="{FF2B5EF4-FFF2-40B4-BE49-F238E27FC236}">
-                <a16:creationId xmlns:a16="http://schemas.microsoft.com/office/drawing/2014/main" id="{B25E0BD4-3DB3-46C1-A179-90D3C07353AF}"/>
+                <a16:creationId xmlns:a16="http://schemas.microsoft.com/office/drawing/2014/main" id="{B2067CE6-84EF-43D6-A2FF-4DFEB44302AE}"/>
               </a:ext>
             </a:extLst>
           </p:cNvPr>
@@ -4773,7 +4866,7 @@
           <p:cNvPr id="12" name="">
             <a:extLst xmlns:a="http://schemas.openxmlformats.org/drawingml/2006/main">
               <a:ext uri="{FF2B5EF4-FFF2-40B4-BE49-F238E27FC236}">
-                <a16:creationId xmlns:a16="http://schemas.microsoft.com/office/drawing/2014/main" id="{1061E751-3D52-4173-8EAC-EDE41A6E08BB}"/>
+                <a16:creationId xmlns:a16="http://schemas.microsoft.com/office/drawing/2014/main" id="{BB642057-BF37-4929-BA58-DECC3674E7A8}"/>
               </a:ext>
             </a:extLst>
           </p:cNvPr>
@@ -4834,7 +4927,7 @@
           <p:cNvPr id="13" name="">
             <a:extLst xmlns:a="http://schemas.openxmlformats.org/drawingml/2006/main">
               <a:ext uri="{FF2B5EF4-FFF2-40B4-BE49-F238E27FC236}">
-                <a16:creationId xmlns:a16="http://schemas.microsoft.com/office/drawing/2014/main" id="{9100CD8A-E5A7-40E7-89E7-ABD2697EE221}"/>
+                <a16:creationId xmlns:a16="http://schemas.microsoft.com/office/drawing/2014/main" id="{688A6EF8-EDEF-4138-8293-5CE979AC866D}"/>
               </a:ext>
             </a:extLst>
           </p:cNvPr>
@@ -4895,7 +4988,7 @@
           <p:cNvPr id="14" name="">
             <a:extLst xmlns:a="http://schemas.openxmlformats.org/drawingml/2006/main">
               <a:ext uri="{FF2B5EF4-FFF2-40B4-BE49-F238E27FC236}">
-                <a16:creationId xmlns:a16="http://schemas.microsoft.com/office/drawing/2014/main" id="{C8431836-C561-472D-8F67-E181BD330242}"/>
+                <a16:creationId xmlns:a16="http://schemas.microsoft.com/office/drawing/2014/main" id="{9F52F725-8887-422A-98F5-A0C0E058F1D9}"/>
               </a:ext>
             </a:extLst>
           </p:cNvPr>
@@ -4927,7 +5020,7 @@
           <p:cNvPr id="15" name="">
             <a:extLst xmlns:a="http://schemas.openxmlformats.org/drawingml/2006/main">
               <a:ext uri="{FF2B5EF4-FFF2-40B4-BE49-F238E27FC236}">
-                <a16:creationId xmlns:a16="http://schemas.microsoft.com/office/drawing/2014/main" id="{EC9E85D4-6858-413B-BBB0-4CCD9FB34E3F}"/>
+                <a16:creationId xmlns:a16="http://schemas.microsoft.com/office/drawing/2014/main" id="{347358A2-52F3-46CC-80FB-53A5CB64F495}"/>
               </a:ext>
             </a:extLst>
           </p:cNvPr>
@@ -4988,7 +5081,7 @@
           <p:cNvPr id="16" name="">
             <a:extLst xmlns:a="http://schemas.openxmlformats.org/drawingml/2006/main">
               <a:ext uri="{FF2B5EF4-FFF2-40B4-BE49-F238E27FC236}">
-                <a16:creationId xmlns:a16="http://schemas.microsoft.com/office/drawing/2014/main" id="{DAC7476D-7002-400F-8B58-9ACCB6A0EDCF}"/>
+                <a16:creationId xmlns:a16="http://schemas.microsoft.com/office/drawing/2014/main" id="{13F79C40-681C-4AE7-8F7C-DBC078421750}"/>
               </a:ext>
             </a:extLst>
           </p:cNvPr>
@@ -5049,7 +5142,7 @@
           <p:cNvPr id="17" name="">
             <a:extLst xmlns:a="http://schemas.openxmlformats.org/drawingml/2006/main">
               <a:ext uri="{FF2B5EF4-FFF2-40B4-BE49-F238E27FC236}">
-                <a16:creationId xmlns:a16="http://schemas.microsoft.com/office/drawing/2014/main" id="{1899C446-A415-4560-9EF5-5DBF9DC5B081}"/>
+                <a16:creationId xmlns:a16="http://schemas.microsoft.com/office/drawing/2014/main" id="{0F5CC82E-B1C2-41A2-9848-46D221EA790D}"/>
               </a:ext>
             </a:extLst>
           </p:cNvPr>
@@ -5081,7 +5174,7 @@
           <p:cNvPr id="18" name="">
             <a:extLst xmlns:a="http://schemas.openxmlformats.org/drawingml/2006/main">
               <a:ext uri="{FF2B5EF4-FFF2-40B4-BE49-F238E27FC236}">
-                <a16:creationId xmlns:a16="http://schemas.microsoft.com/office/drawing/2014/main" id="{BC24C154-3911-4F55-8985-F3515636E2A9}"/>
+                <a16:creationId xmlns:a16="http://schemas.microsoft.com/office/drawing/2014/main" id="{3B9EEA33-95FB-44B0-BF90-8F1E042DC7E0}"/>
               </a:ext>
             </a:extLst>
           </p:cNvPr>
@@ -5142,7 +5235,7 @@
           <p:cNvPr id="19" name="">
             <a:extLst xmlns:a="http://schemas.openxmlformats.org/drawingml/2006/main">
               <a:ext uri="{FF2B5EF4-FFF2-40B4-BE49-F238E27FC236}">
-                <a16:creationId xmlns:a16="http://schemas.microsoft.com/office/drawing/2014/main" id="{E3F8EAB9-8800-4B29-A8A7-2F8480D09B07}"/>
+                <a16:creationId xmlns:a16="http://schemas.microsoft.com/office/drawing/2014/main" id="{78E7BB4A-9747-4EDD-9115-5C14632E98E6}"/>
               </a:ext>
             </a:extLst>
           </p:cNvPr>
@@ -5203,7 +5296,7 @@
           <p:cNvPr id="20" name="">
             <a:extLst xmlns:a="http://schemas.openxmlformats.org/drawingml/2006/main">
               <a:ext uri="{FF2B5EF4-FFF2-40B4-BE49-F238E27FC236}">
-                <a16:creationId xmlns:a16="http://schemas.microsoft.com/office/drawing/2014/main" id="{8CD8AA8A-9037-4088-A008-0F72D659D1CE}"/>
+                <a16:creationId xmlns:a16="http://schemas.microsoft.com/office/drawing/2014/main" id="{841C1085-18C9-46BF-AA11-139414E0A32D}"/>
               </a:ext>
             </a:extLst>
           </p:cNvPr>
@@ -5237,7 +5330,7 @@
           <p:cNvPr id="21" name="">
             <a:extLst xmlns:a="http://schemas.openxmlformats.org/drawingml/2006/main">
               <a:ext uri="{FF2B5EF4-FFF2-40B4-BE49-F238E27FC236}">
-                <a16:creationId xmlns:a16="http://schemas.microsoft.com/office/drawing/2014/main" id="{B8728E1B-C590-421E-88E3-196D90CB359F}"/>
+                <a16:creationId xmlns:a16="http://schemas.microsoft.com/office/drawing/2014/main" id="{2CE3BE9D-44D3-46CA-9130-00FDE5D537F9}"/>
               </a:ext>
             </a:extLst>
           </p:cNvPr>
@@ -5298,7 +5391,7 @@
           <p:cNvPr id="22" name="">
             <a:extLst xmlns:a="http://schemas.openxmlformats.org/drawingml/2006/main">
               <a:ext uri="{FF2B5EF4-FFF2-40B4-BE49-F238E27FC236}">
-                <a16:creationId xmlns:a16="http://schemas.microsoft.com/office/drawing/2014/main" id="{9EAEA243-9B4F-46EF-A2E6-F3F7279E6D8B}"/>
+                <a16:creationId xmlns:a16="http://schemas.microsoft.com/office/drawing/2014/main" id="{51A53A41-4C7F-4C65-84E0-F1B02AA6B95A}"/>
               </a:ext>
             </a:extLst>
           </p:cNvPr>
@@ -5359,7 +5452,7 @@
           <p:cNvPr id="23" name="">
             <a:extLst xmlns:a="http://schemas.openxmlformats.org/drawingml/2006/main">
               <a:ext uri="{FF2B5EF4-FFF2-40B4-BE49-F238E27FC236}">
-                <a16:creationId xmlns:a16="http://schemas.microsoft.com/office/drawing/2014/main" id="{46736025-1E41-4E31-B9CB-638964AC999D}"/>
+                <a16:creationId xmlns:a16="http://schemas.microsoft.com/office/drawing/2014/main" id="{567F4151-9A27-4A13-8C7B-C09257FCA3FB}"/>
               </a:ext>
             </a:extLst>
           </p:cNvPr>
@@ -5420,7 +5513,7 @@
           <p:cNvPr id="24" name="">
             <a:extLst xmlns:a="http://schemas.openxmlformats.org/drawingml/2006/main">
               <a:ext uri="{FF2B5EF4-FFF2-40B4-BE49-F238E27FC236}">
-                <a16:creationId xmlns:a16="http://schemas.microsoft.com/office/drawing/2014/main" id="{D4DB4D01-84FE-4228-863E-AAAED97362A8}"/>
+                <a16:creationId xmlns:a16="http://schemas.microsoft.com/office/drawing/2014/main" id="{D20C443B-22E9-423B-857B-24B16F68671B}"/>
               </a:ext>
             </a:extLst>
           </p:cNvPr>
@@ -5508,7 +5601,7 @@
           <p:cNvPr id="25" name="">
             <a:extLst xmlns:a="http://schemas.openxmlformats.org/drawingml/2006/main">
               <a:ext uri="{FF2B5EF4-FFF2-40B4-BE49-F238E27FC236}">
-                <a16:creationId xmlns:a16="http://schemas.microsoft.com/office/drawing/2014/main" id="{AC724612-C843-4E63-BD19-0EF1A604D215}"/>
+                <a16:creationId xmlns:a16="http://schemas.microsoft.com/office/drawing/2014/main" id="{C95589F5-DCA6-46D8-9A13-BB6CE8B764DE}"/>
               </a:ext>
             </a:extLst>
           </p:cNvPr>
@@ -5542,7 +5635,7 @@
           <p:cNvPr id="26" name="">
             <a:extLst xmlns:a="http://schemas.openxmlformats.org/drawingml/2006/main">
               <a:ext uri="{FF2B5EF4-FFF2-40B4-BE49-F238E27FC236}">
-                <a16:creationId xmlns:a16="http://schemas.microsoft.com/office/drawing/2014/main" id="{46446474-F867-4AC5-A7CB-F5A5E8708314}"/>
+                <a16:creationId xmlns:a16="http://schemas.microsoft.com/office/drawing/2014/main" id="{992C2E78-CFE1-4C57-8232-9E89B175A70B}"/>
               </a:ext>
             </a:extLst>
           </p:cNvPr>
@@ -5603,7 +5696,7 @@
           <p:cNvPr id="27" name="">
             <a:extLst xmlns:a="http://schemas.openxmlformats.org/drawingml/2006/main">
               <a:ext uri="{FF2B5EF4-FFF2-40B4-BE49-F238E27FC236}">
-                <a16:creationId xmlns:a16="http://schemas.microsoft.com/office/drawing/2014/main" id="{585271BB-2C91-4025-BF95-966D2D5A6347}"/>
+                <a16:creationId xmlns:a16="http://schemas.microsoft.com/office/drawing/2014/main" id="{3AAC4442-ECA2-42E9-B0EA-8EBD3B223732}"/>
               </a:ext>
             </a:extLst>
           </p:cNvPr>
@@ -5664,7 +5757,7 @@
           <p:cNvPr id="28" name="">
             <a:extLst xmlns:a="http://schemas.openxmlformats.org/drawingml/2006/main">
               <a:ext uri="{FF2B5EF4-FFF2-40B4-BE49-F238E27FC236}">
-                <a16:creationId xmlns:a16="http://schemas.microsoft.com/office/drawing/2014/main" id="{72D20953-ABCB-4ABA-834E-B54DD26BB6E9}"/>
+                <a16:creationId xmlns:a16="http://schemas.microsoft.com/office/drawing/2014/main" id="{BF0ABCDC-6958-4F83-AEB7-CE977BB78930}"/>
               </a:ext>
             </a:extLst>
           </p:cNvPr>
@@ -5725,7 +5818,7 @@
           <p:cNvPr id="29" name="">
             <a:extLst xmlns:a="http://schemas.openxmlformats.org/drawingml/2006/main">
               <a:ext uri="{FF2B5EF4-FFF2-40B4-BE49-F238E27FC236}">
-                <a16:creationId xmlns:a16="http://schemas.microsoft.com/office/drawing/2014/main" id="{542EC252-9CC0-4712-9A96-1A6A3C7BA197}"/>
+                <a16:creationId xmlns:a16="http://schemas.microsoft.com/office/drawing/2014/main" id="{2415A3DB-0D12-493A-95F3-0B00536DD194}"/>
               </a:ext>
             </a:extLst>
           </p:cNvPr>
@@ -5813,7 +5906,7 @@
           <p:cNvPr id="30" name="">
             <a:extLst xmlns:a="http://schemas.openxmlformats.org/drawingml/2006/main">
               <a:ext uri="{FF2B5EF4-FFF2-40B4-BE49-F238E27FC236}">
-                <a16:creationId xmlns:a16="http://schemas.microsoft.com/office/drawing/2014/main" id="{918153A2-3CF7-4E9A-ABD9-7C1C4D5F76B8}"/>
+                <a16:creationId xmlns:a16="http://schemas.microsoft.com/office/drawing/2014/main" id="{5D560BEC-9734-4F13-A024-A4A39C604C58}"/>
               </a:ext>
             </a:extLst>
           </p:cNvPr>
@@ -5874,7 +5967,7 @@
           <p:cNvPr id="31" name="">
             <a:extLst xmlns:a="http://schemas.openxmlformats.org/drawingml/2006/main">
               <a:ext uri="{FF2B5EF4-FFF2-40B4-BE49-F238E27FC236}">
-                <a16:creationId xmlns:a16="http://schemas.microsoft.com/office/drawing/2014/main" id="{D663563E-D5BF-48A0-A83F-E591A9B2CE62}"/>
+                <a16:creationId xmlns:a16="http://schemas.microsoft.com/office/drawing/2014/main" id="{44A73434-E8A8-4972-A141-D3ED179ABFE8}"/>
               </a:ext>
             </a:extLst>
           </p:cNvPr>
@@ -5933,7 +6026,7 @@
     </p:spTree>
     <p:extLst>
       <p:ext uri="{BB962C8B-B14F-4D97-AF65-F5344CB8AC3E}">
-        <p14:creationId xmlns:p14="http://schemas.microsoft.com/office/powerpoint/2010/main" val="962345197"/>
+        <p14:creationId xmlns:p14="http://schemas.microsoft.com/office/powerpoint/2010/main" val="2011969745"/>
       </p:ext>
     </p:extLst>
   </p:cSld>
@@ -5964,7 +6057,7 @@
           <p:cNvPr id="30" name="">
             <a:extLst xmlns:a="http://schemas.openxmlformats.org/drawingml/2006/main">
               <a:ext uri="{FF2B5EF4-FFF2-40B4-BE49-F238E27FC236}">
-                <a16:creationId xmlns:a16="http://schemas.microsoft.com/office/drawing/2014/main" id="{DBE5B5C6-980B-4F86-9B80-C79510595B50}"/>
+                <a16:creationId xmlns:a16="http://schemas.microsoft.com/office/drawing/2014/main" id="{24E0BD8F-20D7-43EC-95A5-FF617D79A945}"/>
               </a:ext>
             </a:extLst>
           </p:cNvPr>
@@ -6025,7 +6118,7 @@
           <p:cNvPr id="2" name="">
             <a:extLst xmlns:a="http://schemas.openxmlformats.org/drawingml/2006/main">
               <a:ext uri="{FF2B5EF4-FFF2-40B4-BE49-F238E27FC236}">
-                <a16:creationId xmlns:a16="http://schemas.microsoft.com/office/drawing/2014/main" id="{F20FEC33-A446-44C5-9955-F78F1F24D450}"/>
+                <a16:creationId xmlns:a16="http://schemas.microsoft.com/office/drawing/2014/main" id="{B29AC7BD-8F9E-46AC-846D-AB198DF20DB6}"/>
               </a:ext>
             </a:extLst>
           </p:cNvPr>
@@ -6086,7 +6179,7 @@
           <p:cNvPr id="3" name="">
             <a:extLst xmlns:a="http://schemas.openxmlformats.org/drawingml/2006/main">
               <a:ext uri="{FF2B5EF4-FFF2-40B4-BE49-F238E27FC236}">
-                <a16:creationId xmlns:a16="http://schemas.microsoft.com/office/drawing/2014/main" id="{1A8E724A-CD46-4A2B-92AC-0A2CAEC262C1}"/>
+                <a16:creationId xmlns:a16="http://schemas.microsoft.com/office/drawing/2014/main" id="{AACB2801-1FD2-4B2C-8835-23D6E643FC3D}"/>
               </a:ext>
             </a:extLst>
           </p:cNvPr>
@@ -6116,7 +6209,7 @@
           <p:cNvPr id="4" name="">
             <a:extLst xmlns:a="http://schemas.openxmlformats.org/drawingml/2006/main">
               <a:ext uri="{FF2B5EF4-FFF2-40B4-BE49-F238E27FC236}">
-                <a16:creationId xmlns:a16="http://schemas.microsoft.com/office/drawing/2014/main" id="{0180729E-EFCF-405C-9C2C-CA3D5B919508}"/>
+                <a16:creationId xmlns:a16="http://schemas.microsoft.com/office/drawing/2014/main" id="{E571DF71-CFD0-4001-8137-EFA58BFF7106}"/>
               </a:ext>
             </a:extLst>
           </p:cNvPr>
@@ -6177,7 +6270,7 @@
           <p:cNvPr id="5" name="">
             <a:extLst xmlns:a="http://schemas.openxmlformats.org/drawingml/2006/main">
               <a:ext uri="{FF2B5EF4-FFF2-40B4-BE49-F238E27FC236}">
-                <a16:creationId xmlns:a16="http://schemas.microsoft.com/office/drawing/2014/main" id="{1248EA4D-AF70-4863-864A-A57706540DD5}"/>
+                <a16:creationId xmlns:a16="http://schemas.microsoft.com/office/drawing/2014/main" id="{68704B8F-771F-4D7D-81DF-94E0D09D1EF3}"/>
               </a:ext>
             </a:extLst>
           </p:cNvPr>
@@ -6211,7 +6304,7 @@
           <p:cNvPr id="6" name="">
             <a:extLst xmlns:a="http://schemas.openxmlformats.org/drawingml/2006/main">
               <a:ext uri="{FF2B5EF4-FFF2-40B4-BE49-F238E27FC236}">
-                <a16:creationId xmlns:a16="http://schemas.microsoft.com/office/drawing/2014/main" id="{4BDFB6F7-4992-48DE-A61B-8C93CD9FB08F}"/>
+                <a16:creationId xmlns:a16="http://schemas.microsoft.com/office/drawing/2014/main" id="{8BDF019D-32D9-438C-992F-1ECA4DA96A13}"/>
               </a:ext>
             </a:extLst>
           </p:cNvPr>
@@ -6272,7 +6365,7 @@
           <p:cNvPr id="7" name="">
             <a:extLst xmlns:a="http://schemas.openxmlformats.org/drawingml/2006/main">
               <a:ext uri="{FF2B5EF4-FFF2-40B4-BE49-F238E27FC236}">
-                <a16:creationId xmlns:a16="http://schemas.microsoft.com/office/drawing/2014/main" id="{35FAB548-0905-464B-92D3-5E87E9E859F0}"/>
+                <a16:creationId xmlns:a16="http://schemas.microsoft.com/office/drawing/2014/main" id="{828BC3FA-2C77-49AA-8674-8E94F571C3B0}"/>
               </a:ext>
             </a:extLst>
           </p:cNvPr>
@@ -6333,7 +6426,7 @@
           <p:cNvPr id="8" name="">
             <a:extLst xmlns:a="http://schemas.openxmlformats.org/drawingml/2006/main">
               <a:ext uri="{FF2B5EF4-FFF2-40B4-BE49-F238E27FC236}">
-                <a16:creationId xmlns:a16="http://schemas.microsoft.com/office/drawing/2014/main" id="{804D3C86-E974-479E-9183-DEA1393F5FFB}"/>
+                <a16:creationId xmlns:a16="http://schemas.microsoft.com/office/drawing/2014/main" id="{367E492C-4F68-49C3-80E8-EF954324F9B1}"/>
               </a:ext>
             </a:extLst>
           </p:cNvPr>
@@ -6394,7 +6487,7 @@
           <p:cNvPr id="9" name="">
             <a:extLst xmlns:a="http://schemas.openxmlformats.org/drawingml/2006/main">
               <a:ext uri="{FF2B5EF4-FFF2-40B4-BE49-F238E27FC236}">
-                <a16:creationId xmlns:a16="http://schemas.microsoft.com/office/drawing/2014/main" id="{E2625095-42AA-481F-9C14-4706B8250427}"/>
+                <a16:creationId xmlns:a16="http://schemas.microsoft.com/office/drawing/2014/main" id="{2645F834-1F71-447A-B9FB-C17A798A795F}"/>
               </a:ext>
             </a:extLst>
           </p:cNvPr>
@@ -6455,7 +6548,7 @@
           <p:cNvPr id="10" name="">
             <a:extLst xmlns:a="http://schemas.openxmlformats.org/drawingml/2006/main">
               <a:ext uri="{FF2B5EF4-FFF2-40B4-BE49-F238E27FC236}">
-                <a16:creationId xmlns:a16="http://schemas.microsoft.com/office/drawing/2014/main" id="{225BA9FE-4755-4CC0-9DD8-33A1890D56C9}"/>
+                <a16:creationId xmlns:a16="http://schemas.microsoft.com/office/drawing/2014/main" id="{032DC00F-9B05-43BD-B2AA-C3E752760937}"/>
               </a:ext>
             </a:extLst>
           </p:cNvPr>
@@ -6487,7 +6580,7 @@
           <p:cNvPr id="11" name="">
             <a:extLst xmlns:a="http://schemas.openxmlformats.org/drawingml/2006/main">
               <a:ext uri="{FF2B5EF4-FFF2-40B4-BE49-F238E27FC236}">
-                <a16:creationId xmlns:a16="http://schemas.microsoft.com/office/drawing/2014/main" id="{D21CF2D2-1FF7-4530-811A-7BEAE8EBB6BA}"/>
+                <a16:creationId xmlns:a16="http://schemas.microsoft.com/office/drawing/2014/main" id="{909BA48C-F44C-4082-A087-25ABE63E6027}"/>
               </a:ext>
             </a:extLst>
           </p:cNvPr>
@@ -6548,7 +6641,7 @@
           <p:cNvPr id="12" name="">
             <a:extLst xmlns:a="http://schemas.openxmlformats.org/drawingml/2006/main">
               <a:ext uri="{FF2B5EF4-FFF2-40B4-BE49-F238E27FC236}">
-                <a16:creationId xmlns:a16="http://schemas.microsoft.com/office/drawing/2014/main" id="{7F6EF7D0-F05D-40B5-A242-EEFD44CF402D}"/>
+                <a16:creationId xmlns:a16="http://schemas.microsoft.com/office/drawing/2014/main" id="{628647E2-B5BE-46C4-938D-8EB3EFB0D739}"/>
               </a:ext>
             </a:extLst>
           </p:cNvPr>
@@ -6609,7 +6702,7 @@
           <p:cNvPr id="13" name="">
             <a:extLst xmlns:a="http://schemas.openxmlformats.org/drawingml/2006/main">
               <a:ext uri="{FF2B5EF4-FFF2-40B4-BE49-F238E27FC236}">
-                <a16:creationId xmlns:a16="http://schemas.microsoft.com/office/drawing/2014/main" id="{8D7F883C-EA6F-4EF5-8AD8-7FC98A4AC580}"/>
+                <a16:creationId xmlns:a16="http://schemas.microsoft.com/office/drawing/2014/main" id="{38078183-CEF1-4A6E-90A5-EA6651897927}"/>
               </a:ext>
             </a:extLst>
           </p:cNvPr>
@@ -6643,7 +6736,7 @@
           <p:cNvPr id="14" name="">
             <a:extLst xmlns:a="http://schemas.openxmlformats.org/drawingml/2006/main">
               <a:ext uri="{FF2B5EF4-FFF2-40B4-BE49-F238E27FC236}">
-                <a16:creationId xmlns:a16="http://schemas.microsoft.com/office/drawing/2014/main" id="{C7FF25BD-5BB7-48B5-9B63-6895BBD1C453}"/>
+                <a16:creationId xmlns:a16="http://schemas.microsoft.com/office/drawing/2014/main" id="{6EEE87F8-C96F-47EF-A005-442AF5F4944A}"/>
               </a:ext>
             </a:extLst>
           </p:cNvPr>
@@ -6704,7 +6797,7 @@
           <p:cNvPr id="15" name="">
             <a:extLst xmlns:a="http://schemas.openxmlformats.org/drawingml/2006/main">
               <a:ext uri="{FF2B5EF4-FFF2-40B4-BE49-F238E27FC236}">
-                <a16:creationId xmlns:a16="http://schemas.microsoft.com/office/drawing/2014/main" id="{07F7E420-CB1D-4E9B-8C9C-309BC0A685D7}"/>
+                <a16:creationId xmlns:a16="http://schemas.microsoft.com/office/drawing/2014/main" id="{322A2E8D-CEB5-4972-BD0D-34435947DC52}"/>
               </a:ext>
             </a:extLst>
           </p:cNvPr>
@@ -6765,7 +6858,7 @@
           <p:cNvPr id="16" name="">
             <a:extLst xmlns:a="http://schemas.openxmlformats.org/drawingml/2006/main">
               <a:ext uri="{FF2B5EF4-FFF2-40B4-BE49-F238E27FC236}">
-                <a16:creationId xmlns:a16="http://schemas.microsoft.com/office/drawing/2014/main" id="{5FFC169E-5843-4BA9-ACBF-C68BA692CFB9}"/>
+                <a16:creationId xmlns:a16="http://schemas.microsoft.com/office/drawing/2014/main" id="{7EAF77FE-5D12-46DD-AE00-ACFA79AB8548}"/>
               </a:ext>
             </a:extLst>
           </p:cNvPr>
@@ -6799,7 +6892,7 @@
           <p:cNvPr id="17" name="">
             <a:extLst xmlns:a="http://schemas.openxmlformats.org/drawingml/2006/main">
               <a:ext uri="{FF2B5EF4-FFF2-40B4-BE49-F238E27FC236}">
-                <a16:creationId xmlns:a16="http://schemas.microsoft.com/office/drawing/2014/main" id="{8ED019EE-662E-4E5B-BA4F-C96D32D98DFE}"/>
+                <a16:creationId xmlns:a16="http://schemas.microsoft.com/office/drawing/2014/main" id="{322CAEC6-F851-4EF3-9178-BA87BE0E4DE2}"/>
               </a:ext>
             </a:extLst>
           </p:cNvPr>
@@ -6860,7 +6953,7 @@
           <p:cNvPr id="18" name="">
             <a:extLst xmlns:a="http://schemas.openxmlformats.org/drawingml/2006/main">
               <a:ext uri="{FF2B5EF4-FFF2-40B4-BE49-F238E27FC236}">
-                <a16:creationId xmlns:a16="http://schemas.microsoft.com/office/drawing/2014/main" id="{2A32C6F3-0226-4D28-A558-260686CF8713}"/>
+                <a16:creationId xmlns:a16="http://schemas.microsoft.com/office/drawing/2014/main" id="{424B0F85-EA20-4B61-919A-B09CBDB93092}"/>
               </a:ext>
             </a:extLst>
           </p:cNvPr>
@@ -6921,7 +7014,7 @@
           <p:cNvPr id="19" name="">
             <a:extLst xmlns:a="http://schemas.openxmlformats.org/drawingml/2006/main">
               <a:ext uri="{FF2B5EF4-FFF2-40B4-BE49-F238E27FC236}">
-                <a16:creationId xmlns:a16="http://schemas.microsoft.com/office/drawing/2014/main" id="{3A72975B-56C9-4FBF-BAC0-B53CB0D10643}"/>
+                <a16:creationId xmlns:a16="http://schemas.microsoft.com/office/drawing/2014/main" id="{CB0D196C-65A2-4422-B9DC-37CBD84CAD51}"/>
               </a:ext>
             </a:extLst>
           </p:cNvPr>
@@ -6953,7 +7046,7 @@
           <p:cNvPr id="20" name="">
             <a:extLst xmlns:a="http://schemas.openxmlformats.org/drawingml/2006/main">
               <a:ext uri="{FF2B5EF4-FFF2-40B4-BE49-F238E27FC236}">
-                <a16:creationId xmlns:a16="http://schemas.microsoft.com/office/drawing/2014/main" id="{95AD2058-B324-4C7D-A7EB-F71BAB964943}"/>
+                <a16:creationId xmlns:a16="http://schemas.microsoft.com/office/drawing/2014/main" id="{0805AFA3-1048-4984-9304-58EA73108FFB}"/>
               </a:ext>
             </a:extLst>
           </p:cNvPr>
@@ -6985,7 +7078,7 @@
           <p:cNvPr id="21" name="">
             <a:extLst xmlns:a="http://schemas.openxmlformats.org/drawingml/2006/main">
               <a:ext uri="{FF2B5EF4-FFF2-40B4-BE49-F238E27FC236}">
-                <a16:creationId xmlns:a16="http://schemas.microsoft.com/office/drawing/2014/main" id="{6C523793-E2EF-46E8-9260-5D590DD4B3C2}"/>
+                <a16:creationId xmlns:a16="http://schemas.microsoft.com/office/drawing/2014/main" id="{9A642405-EFAF-4A06-AAF0-23776420E1EB}"/>
               </a:ext>
             </a:extLst>
           </p:cNvPr>
@@ -7046,7 +7139,7 @@
           <p:cNvPr id="22" name="">
             <a:extLst xmlns:a="http://schemas.openxmlformats.org/drawingml/2006/main">
               <a:ext uri="{FF2B5EF4-FFF2-40B4-BE49-F238E27FC236}">
-                <a16:creationId xmlns:a16="http://schemas.microsoft.com/office/drawing/2014/main" id="{FEBFB8DC-AAC9-498E-B192-6F2C2D85CDD0}"/>
+                <a16:creationId xmlns:a16="http://schemas.microsoft.com/office/drawing/2014/main" id="{A0BFA83F-80A0-4C66-9671-BB93BA74D640}"/>
               </a:ext>
             </a:extLst>
           </p:cNvPr>
@@ -7107,7 +7200,7 @@
           <p:cNvPr id="23" name="">
             <a:extLst xmlns:a="http://schemas.openxmlformats.org/drawingml/2006/main">
               <a:ext uri="{FF2B5EF4-FFF2-40B4-BE49-F238E27FC236}">
-                <a16:creationId xmlns:a16="http://schemas.microsoft.com/office/drawing/2014/main" id="{65386E58-8946-416F-AE0E-0A04A581F4EB}"/>
+                <a16:creationId xmlns:a16="http://schemas.microsoft.com/office/drawing/2014/main" id="{4A746520-4618-4B96-AFF6-BBA4067FEE4A}"/>
               </a:ext>
             </a:extLst>
           </p:cNvPr>
@@ -7168,7 +7261,7 @@
           <p:cNvPr id="24" name="">
             <a:extLst xmlns:a="http://schemas.openxmlformats.org/drawingml/2006/main">
               <a:ext uri="{FF2B5EF4-FFF2-40B4-BE49-F238E27FC236}">
-                <a16:creationId xmlns:a16="http://schemas.microsoft.com/office/drawing/2014/main" id="{7C881BDC-66D5-4F82-946B-AB4D4CA08952}"/>
+                <a16:creationId xmlns:a16="http://schemas.microsoft.com/office/drawing/2014/main" id="{F4A9B1C5-E322-427C-B96A-2A5293832A6F}"/>
               </a:ext>
             </a:extLst>
           </p:cNvPr>
@@ -7229,7 +7322,7 @@
           <p:cNvPr id="25" name="">
             <a:extLst xmlns:a="http://schemas.openxmlformats.org/drawingml/2006/main">
               <a:ext uri="{FF2B5EF4-FFF2-40B4-BE49-F238E27FC236}">
-                <a16:creationId xmlns:a16="http://schemas.microsoft.com/office/drawing/2014/main" id="{07D26D57-355D-404C-BDEB-EF128588A31B}"/>
+                <a16:creationId xmlns:a16="http://schemas.microsoft.com/office/drawing/2014/main" id="{EC4B0DA9-DA86-42BA-B3DE-8C0650C63154}"/>
               </a:ext>
             </a:extLst>
           </p:cNvPr>
@@ -7263,7 +7356,7 @@
           <p:cNvPr id="26" name="">
             <a:extLst xmlns:a="http://schemas.openxmlformats.org/drawingml/2006/main">
               <a:ext uri="{FF2B5EF4-FFF2-40B4-BE49-F238E27FC236}">
-                <a16:creationId xmlns:a16="http://schemas.microsoft.com/office/drawing/2014/main" id="{A9DF196E-4437-43C1-8325-A60846ABB3A4}"/>
+                <a16:creationId xmlns:a16="http://schemas.microsoft.com/office/drawing/2014/main" id="{6035D0EE-CF48-48F5-A4B0-C468F3924DE6}"/>
               </a:ext>
             </a:extLst>
           </p:cNvPr>
@@ -7324,7 +7417,7 @@
           <p:cNvPr id="27" name="">
             <a:extLst xmlns:a="http://schemas.openxmlformats.org/drawingml/2006/main">
               <a:ext uri="{FF2B5EF4-FFF2-40B4-BE49-F238E27FC236}">
-                <a16:creationId xmlns:a16="http://schemas.microsoft.com/office/drawing/2014/main" id="{23AB9E44-6BA2-4038-8E99-A42F94B66A06}"/>
+                <a16:creationId xmlns:a16="http://schemas.microsoft.com/office/drawing/2014/main" id="{515FBD2F-A731-45A2-A1DF-DE139FCB3EBD}"/>
               </a:ext>
             </a:extLst>
           </p:cNvPr>
@@ -7385,7 +7478,7 @@
           <p:cNvPr id="28" name="">
             <a:extLst xmlns:a="http://schemas.openxmlformats.org/drawingml/2006/main">
               <a:ext uri="{FF2B5EF4-FFF2-40B4-BE49-F238E27FC236}">
-                <a16:creationId xmlns:a16="http://schemas.microsoft.com/office/drawing/2014/main" id="{28B49811-7440-40EF-B727-4511B2979E73}"/>
+                <a16:creationId xmlns:a16="http://schemas.microsoft.com/office/drawing/2014/main" id="{78BDDEA3-8371-44E1-BA81-2C23BA235D82}"/>
               </a:ext>
             </a:extLst>
           </p:cNvPr>
@@ -7446,7 +7539,7 @@
           <p:cNvPr id="29" name="">
             <a:extLst xmlns:a="http://schemas.openxmlformats.org/drawingml/2006/main">
               <a:ext uri="{FF2B5EF4-FFF2-40B4-BE49-F238E27FC236}">
-                <a16:creationId xmlns:a16="http://schemas.microsoft.com/office/drawing/2014/main" id="{03928A01-0443-434A-AB43-65DE4BE6D315}"/>
+                <a16:creationId xmlns:a16="http://schemas.microsoft.com/office/drawing/2014/main" id="{89104298-A569-4AE5-83D5-0DC4F49F178F}"/>
               </a:ext>
             </a:extLst>
           </p:cNvPr>
@@ -7505,7 +7598,7 @@
     </p:spTree>
     <p:extLst>
       <p:ext uri="{BB962C8B-B14F-4D97-AF65-F5344CB8AC3E}">
-        <p14:creationId xmlns:p14="http://schemas.microsoft.com/office/powerpoint/2010/main" val="1640756323"/>
+        <p14:creationId xmlns:p14="http://schemas.microsoft.com/office/powerpoint/2010/main" val="853211616"/>
       </p:ext>
     </p:extLst>
   </p:cSld>
@@ -7536,7 +7629,7 @@
           <p:cNvPr id="30" name="">
             <a:extLst xmlns:a="http://schemas.openxmlformats.org/drawingml/2006/main">
               <a:ext uri="{FF2B5EF4-FFF2-40B4-BE49-F238E27FC236}">
-                <a16:creationId xmlns:a16="http://schemas.microsoft.com/office/drawing/2014/main" id="{2BDF99C1-8374-4ECF-83BF-7D1E7DCBD044}"/>
+                <a16:creationId xmlns:a16="http://schemas.microsoft.com/office/drawing/2014/main" id="{A988EEA2-A903-46C9-B493-B02D2C7A680C}"/>
               </a:ext>
             </a:extLst>
           </p:cNvPr>
@@ -7597,7 +7690,7 @@
           <p:cNvPr id="2" name="">
             <a:extLst xmlns:a="http://schemas.openxmlformats.org/drawingml/2006/main">
               <a:ext uri="{FF2B5EF4-FFF2-40B4-BE49-F238E27FC236}">
-                <a16:creationId xmlns:a16="http://schemas.microsoft.com/office/drawing/2014/main" id="{30823705-92FA-40A2-A866-96D580EDA332}"/>
+                <a16:creationId xmlns:a16="http://schemas.microsoft.com/office/drawing/2014/main" id="{3CD3E8DE-F1D4-440F-8934-932F00175CAA}"/>
               </a:ext>
             </a:extLst>
           </p:cNvPr>
@@ -7658,7 +7751,7 @@
           <p:cNvPr id="3" name="">
             <a:extLst xmlns:a="http://schemas.openxmlformats.org/drawingml/2006/main">
               <a:ext uri="{FF2B5EF4-FFF2-40B4-BE49-F238E27FC236}">
-                <a16:creationId xmlns:a16="http://schemas.microsoft.com/office/drawing/2014/main" id="{68D64409-6EED-4E5F-A4B0-E0947585032C}"/>
+                <a16:creationId xmlns:a16="http://schemas.microsoft.com/office/drawing/2014/main" id="{5749D150-2EFD-465D-996A-2871563D4AF5}"/>
               </a:ext>
             </a:extLst>
           </p:cNvPr>
@@ -7688,7 +7781,7 @@
           <p:cNvPr id="4" name="">
             <a:extLst xmlns:a="http://schemas.openxmlformats.org/drawingml/2006/main">
               <a:ext uri="{FF2B5EF4-FFF2-40B4-BE49-F238E27FC236}">
-                <a16:creationId xmlns:a16="http://schemas.microsoft.com/office/drawing/2014/main" id="{75B68A19-369A-4F3F-B91C-FBF100FC5920}"/>
+                <a16:creationId xmlns:a16="http://schemas.microsoft.com/office/drawing/2014/main" id="{146A0C2E-3B78-46F4-9357-E6AF5F3D7306}"/>
               </a:ext>
             </a:extLst>
           </p:cNvPr>
@@ -7749,7 +7842,7 @@
           <p:cNvPr id="5" name="">
             <a:extLst xmlns:a="http://schemas.openxmlformats.org/drawingml/2006/main">
               <a:ext uri="{FF2B5EF4-FFF2-40B4-BE49-F238E27FC236}">
-                <a16:creationId xmlns:a16="http://schemas.microsoft.com/office/drawing/2014/main" id="{0017910F-456C-4DF2-B5D5-01F7916C1A96}"/>
+                <a16:creationId xmlns:a16="http://schemas.microsoft.com/office/drawing/2014/main" id="{8B0E4135-44E7-4DFF-B9F8-DEA08DBC7EAA}"/>
               </a:ext>
             </a:extLst>
           </p:cNvPr>
@@ -7783,7 +7876,7 @@
           <p:cNvPr id="6" name="">
             <a:extLst xmlns:a="http://schemas.openxmlformats.org/drawingml/2006/main">
               <a:ext uri="{FF2B5EF4-FFF2-40B4-BE49-F238E27FC236}">
-                <a16:creationId xmlns:a16="http://schemas.microsoft.com/office/drawing/2014/main" id="{3FF00756-2E31-402A-ACDE-EAA0822484A3}"/>
+                <a16:creationId xmlns:a16="http://schemas.microsoft.com/office/drawing/2014/main" id="{B49E7D29-E18E-465E-8951-01548BD58364}"/>
               </a:ext>
             </a:extLst>
           </p:cNvPr>
@@ -7844,7 +7937,7 @@
           <p:cNvPr id="7" name="">
             <a:extLst xmlns:a="http://schemas.openxmlformats.org/drawingml/2006/main">
               <a:ext uri="{FF2B5EF4-FFF2-40B4-BE49-F238E27FC236}">
-                <a16:creationId xmlns:a16="http://schemas.microsoft.com/office/drawing/2014/main" id="{BF62B9F3-922F-49F6-83CC-15634D658DBB}"/>
+                <a16:creationId xmlns:a16="http://schemas.microsoft.com/office/drawing/2014/main" id="{A27791D7-DA02-4D1E-95C5-81BDCF04EF5E}"/>
               </a:ext>
             </a:extLst>
           </p:cNvPr>
@@ -7905,7 +7998,7 @@
           <p:cNvPr id="8" name="">
             <a:extLst xmlns:a="http://schemas.openxmlformats.org/drawingml/2006/main">
               <a:ext uri="{FF2B5EF4-FFF2-40B4-BE49-F238E27FC236}">
-                <a16:creationId xmlns:a16="http://schemas.microsoft.com/office/drawing/2014/main" id="{3C4F959A-D4A8-4901-BDE5-70739AEDBB18}"/>
+                <a16:creationId xmlns:a16="http://schemas.microsoft.com/office/drawing/2014/main" id="{64166189-089C-4081-AEAB-5CE94DC48E9D}"/>
               </a:ext>
             </a:extLst>
           </p:cNvPr>
@@ -7966,7 +8059,7 @@
           <p:cNvPr id="9" name="">
             <a:extLst xmlns:a="http://schemas.openxmlformats.org/drawingml/2006/main">
               <a:ext uri="{FF2B5EF4-FFF2-40B4-BE49-F238E27FC236}">
-                <a16:creationId xmlns:a16="http://schemas.microsoft.com/office/drawing/2014/main" id="{C63B5CA5-5F91-4C57-A36E-DA7A8CCEA50E}"/>
+                <a16:creationId xmlns:a16="http://schemas.microsoft.com/office/drawing/2014/main" id="{82E4C9EF-F466-47FD-BBC3-6EC83FD1E8D2}"/>
               </a:ext>
             </a:extLst>
           </p:cNvPr>
@@ -8027,7 +8120,7 @@
           <p:cNvPr id="10" name="">
             <a:extLst xmlns:a="http://schemas.openxmlformats.org/drawingml/2006/main">
               <a:ext uri="{FF2B5EF4-FFF2-40B4-BE49-F238E27FC236}">
-                <a16:creationId xmlns:a16="http://schemas.microsoft.com/office/drawing/2014/main" id="{9F086DC9-0E27-40A0-AE51-1B285BDA4DEF}"/>
+                <a16:creationId xmlns:a16="http://schemas.microsoft.com/office/drawing/2014/main" id="{099609CE-29C0-4479-AE99-E34356059AFB}"/>
               </a:ext>
             </a:extLst>
           </p:cNvPr>
@@ -8088,7 +8181,7 @@
           <p:cNvPr id="11" name="">
             <a:extLst xmlns:a="http://schemas.openxmlformats.org/drawingml/2006/main">
               <a:ext uri="{FF2B5EF4-FFF2-40B4-BE49-F238E27FC236}">
-                <a16:creationId xmlns:a16="http://schemas.microsoft.com/office/drawing/2014/main" id="{732849B5-0B18-46BE-A14F-8A0E51C6DB8B}"/>
+                <a16:creationId xmlns:a16="http://schemas.microsoft.com/office/drawing/2014/main" id="{C428BCF1-50BC-4F00-94AA-C4840AD9DFD2}"/>
               </a:ext>
             </a:extLst>
           </p:cNvPr>
@@ -8149,7 +8242,7 @@
           <p:cNvPr id="12" name="">
             <a:extLst xmlns:a="http://schemas.openxmlformats.org/drawingml/2006/main">
               <a:ext uri="{FF2B5EF4-FFF2-40B4-BE49-F238E27FC236}">
-                <a16:creationId xmlns:a16="http://schemas.microsoft.com/office/drawing/2014/main" id="{DB403E97-88DB-4F60-878F-D44B55400253}"/>
+                <a16:creationId xmlns:a16="http://schemas.microsoft.com/office/drawing/2014/main" id="{1ED40EEE-A97B-4D55-9088-8A0F6680D7A8}"/>
               </a:ext>
             </a:extLst>
           </p:cNvPr>
@@ -8210,7 +8303,7 @@
           <p:cNvPr id="13" name="">
             <a:extLst xmlns:a="http://schemas.openxmlformats.org/drawingml/2006/main">
               <a:ext uri="{FF2B5EF4-FFF2-40B4-BE49-F238E27FC236}">
-                <a16:creationId xmlns:a16="http://schemas.microsoft.com/office/drawing/2014/main" id="{0978D00C-B7C8-4834-9AB4-2B6457E79781}"/>
+                <a16:creationId xmlns:a16="http://schemas.microsoft.com/office/drawing/2014/main" id="{A4F82748-807A-46F6-B8BC-56BD4D937FC7}"/>
               </a:ext>
             </a:extLst>
           </p:cNvPr>
@@ -8244,7 +8337,7 @@
           <p:cNvPr id="14" name="">
             <a:extLst xmlns:a="http://schemas.openxmlformats.org/drawingml/2006/main">
               <a:ext uri="{FF2B5EF4-FFF2-40B4-BE49-F238E27FC236}">
-                <a16:creationId xmlns:a16="http://schemas.microsoft.com/office/drawing/2014/main" id="{3BFD5E64-17D0-496C-8EEF-74976A61239A}"/>
+                <a16:creationId xmlns:a16="http://schemas.microsoft.com/office/drawing/2014/main" id="{8CA1277F-E3E3-44AB-AFE0-18AAB4FDEE9B}"/>
               </a:ext>
             </a:extLst>
           </p:cNvPr>
@@ -8305,7 +8398,7 @@
           <p:cNvPr id="15" name="">
             <a:extLst xmlns:a="http://schemas.openxmlformats.org/drawingml/2006/main">
               <a:ext uri="{FF2B5EF4-FFF2-40B4-BE49-F238E27FC236}">
-                <a16:creationId xmlns:a16="http://schemas.microsoft.com/office/drawing/2014/main" id="{2500C68D-8330-4D17-A76E-63DD531BA8F2}"/>
+                <a16:creationId xmlns:a16="http://schemas.microsoft.com/office/drawing/2014/main" id="{4B56887A-9E03-4EBB-B59F-2D111E5E51B2}"/>
               </a:ext>
             </a:extLst>
           </p:cNvPr>
@@ -8366,7 +8459,7 @@
           <p:cNvPr id="16" name="">
             <a:extLst xmlns:a="http://schemas.openxmlformats.org/drawingml/2006/main">
               <a:ext uri="{FF2B5EF4-FFF2-40B4-BE49-F238E27FC236}">
-                <a16:creationId xmlns:a16="http://schemas.microsoft.com/office/drawing/2014/main" id="{45758FCB-C6B2-4F78-886A-59E64D49DDC9}"/>
+                <a16:creationId xmlns:a16="http://schemas.microsoft.com/office/drawing/2014/main" id="{4A761EF1-B1E9-4BF6-8D17-FAAB329C4A93}"/>
               </a:ext>
             </a:extLst>
           </p:cNvPr>
@@ -8427,7 +8520,7 @@
           <p:cNvPr id="17" name="">
             <a:extLst xmlns:a="http://schemas.openxmlformats.org/drawingml/2006/main">
               <a:ext uri="{FF2B5EF4-FFF2-40B4-BE49-F238E27FC236}">
-                <a16:creationId xmlns:a16="http://schemas.microsoft.com/office/drawing/2014/main" id="{48BF84DF-E78B-4919-BAB4-2FE9AC14B317}"/>
+                <a16:creationId xmlns:a16="http://schemas.microsoft.com/office/drawing/2014/main" id="{C2E000B1-2B54-4F7D-918D-5CA08D41A6A7}"/>
               </a:ext>
             </a:extLst>
           </p:cNvPr>
@@ -8488,7 +8581,7 @@
           <p:cNvPr id="18" name="">
             <a:extLst xmlns:a="http://schemas.openxmlformats.org/drawingml/2006/main">
               <a:ext uri="{FF2B5EF4-FFF2-40B4-BE49-F238E27FC236}">
-                <a16:creationId xmlns:a16="http://schemas.microsoft.com/office/drawing/2014/main" id="{4A26D99E-E1B9-4261-9503-55A8D5C46557}"/>
+                <a16:creationId xmlns:a16="http://schemas.microsoft.com/office/drawing/2014/main" id="{0FE97C88-2A14-4AEA-8189-1A917510A8C3}"/>
               </a:ext>
             </a:extLst>
           </p:cNvPr>
@@ -8549,7 +8642,7 @@
           <p:cNvPr id="19" name="">
             <a:extLst xmlns:a="http://schemas.openxmlformats.org/drawingml/2006/main">
               <a:ext uri="{FF2B5EF4-FFF2-40B4-BE49-F238E27FC236}">
-                <a16:creationId xmlns:a16="http://schemas.microsoft.com/office/drawing/2014/main" id="{C313DE94-8EF1-4213-AE02-BA008BEEC958}"/>
+                <a16:creationId xmlns:a16="http://schemas.microsoft.com/office/drawing/2014/main" id="{9F6EEE3A-D21F-4483-9E97-0F3DA701407B}"/>
               </a:ext>
             </a:extLst>
           </p:cNvPr>
@@ -8610,7 +8703,7 @@
           <p:cNvPr id="20" name="">
             <a:extLst xmlns:a="http://schemas.openxmlformats.org/drawingml/2006/main">
               <a:ext uri="{FF2B5EF4-FFF2-40B4-BE49-F238E27FC236}">
-                <a16:creationId xmlns:a16="http://schemas.microsoft.com/office/drawing/2014/main" id="{CADF7E40-3C31-4435-9C95-905AE7F3D991}"/>
+                <a16:creationId xmlns:a16="http://schemas.microsoft.com/office/drawing/2014/main" id="{AD37BE54-6AEB-4F4D-8412-AD8A396884EE}"/>
               </a:ext>
             </a:extLst>
           </p:cNvPr>
@@ -8671,7 +8764,7 @@
           <p:cNvPr id="21" name="">
             <a:extLst xmlns:a="http://schemas.openxmlformats.org/drawingml/2006/main">
               <a:ext uri="{FF2B5EF4-FFF2-40B4-BE49-F238E27FC236}">
-                <a16:creationId xmlns:a16="http://schemas.microsoft.com/office/drawing/2014/main" id="{B8407948-EE97-48D0-AC2E-A5FE46DA7203}"/>
+                <a16:creationId xmlns:a16="http://schemas.microsoft.com/office/drawing/2014/main" id="{8704E548-98FA-45A0-9F57-D019CDF86F24}"/>
               </a:ext>
             </a:extLst>
           </p:cNvPr>
@@ -8703,7 +8796,7 @@
           <p:cNvPr id="22" name="">
             <a:extLst xmlns:a="http://schemas.openxmlformats.org/drawingml/2006/main">
               <a:ext uri="{FF2B5EF4-FFF2-40B4-BE49-F238E27FC236}">
-                <a16:creationId xmlns:a16="http://schemas.microsoft.com/office/drawing/2014/main" id="{AAFF4DAB-36A5-49D4-BD24-3855C1AB24FE}"/>
+                <a16:creationId xmlns:a16="http://schemas.microsoft.com/office/drawing/2014/main" id="{80824978-B9CA-44A9-8CB8-3707885C19BC}"/>
               </a:ext>
             </a:extLst>
           </p:cNvPr>
@@ -8764,7 +8857,7 @@
           <p:cNvPr id="23" name="">
             <a:extLst xmlns:a="http://schemas.openxmlformats.org/drawingml/2006/main">
               <a:ext uri="{FF2B5EF4-FFF2-40B4-BE49-F238E27FC236}">
-                <a16:creationId xmlns:a16="http://schemas.microsoft.com/office/drawing/2014/main" id="{09BAFA56-3124-49E7-BC3E-3C6FB01CCF52}"/>
+                <a16:creationId xmlns:a16="http://schemas.microsoft.com/office/drawing/2014/main" id="{505FAB24-A4DB-4F18-8739-940738E73FE9}"/>
               </a:ext>
             </a:extLst>
           </p:cNvPr>
@@ -8825,7 +8918,7 @@
           <p:cNvPr id="24" name="">
             <a:extLst xmlns:a="http://schemas.openxmlformats.org/drawingml/2006/main">
               <a:ext uri="{FF2B5EF4-FFF2-40B4-BE49-F238E27FC236}">
-                <a16:creationId xmlns:a16="http://schemas.microsoft.com/office/drawing/2014/main" id="{98AE51F0-7544-4DC1-BB28-0C904EB3D6C1}"/>
+                <a16:creationId xmlns:a16="http://schemas.microsoft.com/office/drawing/2014/main" id="{D185B1C3-93D5-4404-B109-1BAA73FA234C}"/>
               </a:ext>
             </a:extLst>
           </p:cNvPr>
@@ -8857,7 +8950,7 @@
           <p:cNvPr id="25" name="">
             <a:extLst xmlns:a="http://schemas.openxmlformats.org/drawingml/2006/main">
               <a:ext uri="{FF2B5EF4-FFF2-40B4-BE49-F238E27FC236}">
-                <a16:creationId xmlns:a16="http://schemas.microsoft.com/office/drawing/2014/main" id="{B58DE7FF-1B96-4E8E-A235-E3EDFC9BF2D0}"/>
+                <a16:creationId xmlns:a16="http://schemas.microsoft.com/office/drawing/2014/main" id="{4BB49375-F1D9-47E6-8EF5-D1F94B870DEC}"/>
               </a:ext>
             </a:extLst>
           </p:cNvPr>
@@ -8918,7 +9011,7 @@
           <p:cNvPr id="26" name="">
             <a:extLst xmlns:a="http://schemas.openxmlformats.org/drawingml/2006/main">
               <a:ext uri="{FF2B5EF4-FFF2-40B4-BE49-F238E27FC236}">
-                <a16:creationId xmlns:a16="http://schemas.microsoft.com/office/drawing/2014/main" id="{E73E0E2A-F2BB-42F3-A095-9B13D5F9AFB5}"/>
+                <a16:creationId xmlns:a16="http://schemas.microsoft.com/office/drawing/2014/main" id="{FF1FF08D-9F33-4338-AB0C-1865A473A7D8}"/>
               </a:ext>
             </a:extLst>
           </p:cNvPr>
@@ -8979,7 +9072,7 @@
           <p:cNvPr id="27" name="">
             <a:extLst xmlns:a="http://schemas.openxmlformats.org/drawingml/2006/main">
               <a:ext uri="{FF2B5EF4-FFF2-40B4-BE49-F238E27FC236}">
-                <a16:creationId xmlns:a16="http://schemas.microsoft.com/office/drawing/2014/main" id="{12EE282A-54D3-44F4-902D-5AADD3FB530F}"/>
+                <a16:creationId xmlns:a16="http://schemas.microsoft.com/office/drawing/2014/main" id="{3032DB19-CA25-4276-ACF4-430E5B32C084}"/>
               </a:ext>
             </a:extLst>
           </p:cNvPr>
@@ -9011,7 +9104,7 @@
           <p:cNvPr id="28" name="">
             <a:extLst xmlns:a="http://schemas.openxmlformats.org/drawingml/2006/main">
               <a:ext uri="{FF2B5EF4-FFF2-40B4-BE49-F238E27FC236}">
-                <a16:creationId xmlns:a16="http://schemas.microsoft.com/office/drawing/2014/main" id="{E46A129F-9866-46FD-9E05-39B4A7435D61}"/>
+                <a16:creationId xmlns:a16="http://schemas.microsoft.com/office/drawing/2014/main" id="{A649DC7B-4E35-4336-A26D-8B777E77BCD1}"/>
               </a:ext>
             </a:extLst>
           </p:cNvPr>
@@ -9072,7 +9165,7 @@
           <p:cNvPr id="29" name="">
             <a:extLst xmlns:a="http://schemas.openxmlformats.org/drawingml/2006/main">
               <a:ext uri="{FF2B5EF4-FFF2-40B4-BE49-F238E27FC236}">
-                <a16:creationId xmlns:a16="http://schemas.microsoft.com/office/drawing/2014/main" id="{13349B22-BFCD-4AAB-955D-6441591D0192}"/>
+                <a16:creationId xmlns:a16="http://schemas.microsoft.com/office/drawing/2014/main" id="{FEE829AA-FE8E-447E-9E64-2405BE10B0A2}"/>
               </a:ext>
             </a:extLst>
           </p:cNvPr>
@@ -9131,7 +9224,7 @@
     </p:spTree>
     <p:extLst>
       <p:ext uri="{BB962C8B-B14F-4D97-AF65-F5344CB8AC3E}">
-        <p14:creationId xmlns:p14="http://schemas.microsoft.com/office/powerpoint/2010/main" val="892981722"/>
+        <p14:creationId xmlns:p14="http://schemas.microsoft.com/office/powerpoint/2010/main" val="1229429784"/>
       </p:ext>
     </p:extLst>
   </p:cSld>
@@ -9162,7 +9255,7 @@
           <p:cNvPr id="14" name="">
             <a:extLst xmlns:a="http://schemas.openxmlformats.org/drawingml/2006/main">
               <a:ext uri="{FF2B5EF4-FFF2-40B4-BE49-F238E27FC236}">
-                <a16:creationId xmlns:a16="http://schemas.microsoft.com/office/drawing/2014/main" id="{F2F267E6-61F2-45D9-B0AF-FAA129137D17}"/>
+                <a16:creationId xmlns:a16="http://schemas.microsoft.com/office/drawing/2014/main" id="{EB2BB647-F12E-423E-A9AC-F3FE348269D8}"/>
               </a:ext>
             </a:extLst>
           </p:cNvPr>
@@ -9223,7 +9316,7 @@
           <p:cNvPr id="2" name="">
             <a:extLst xmlns:a="http://schemas.openxmlformats.org/drawingml/2006/main">
               <a:ext uri="{FF2B5EF4-FFF2-40B4-BE49-F238E27FC236}">
-                <a16:creationId xmlns:a16="http://schemas.microsoft.com/office/drawing/2014/main" id="{667908BC-F6F2-40F0-B811-06958F3D64C2}"/>
+                <a16:creationId xmlns:a16="http://schemas.microsoft.com/office/drawing/2014/main" id="{18B43848-0EFB-4099-80D2-1A1C44EBF252}"/>
               </a:ext>
             </a:extLst>
           </p:cNvPr>
@@ -9284,7 +9377,7 @@
           <p:cNvPr id="3" name="">
             <a:extLst xmlns:a="http://schemas.openxmlformats.org/drawingml/2006/main">
               <a:ext uri="{FF2B5EF4-FFF2-40B4-BE49-F238E27FC236}">
-                <a16:creationId xmlns:a16="http://schemas.microsoft.com/office/drawing/2014/main" id="{344ED4BE-14D5-4F63-B7DD-91F5CF6C05C9}"/>
+                <a16:creationId xmlns:a16="http://schemas.microsoft.com/office/drawing/2014/main" id="{CDD24C77-798A-4EB5-BE14-905ABA1BE9D6}"/>
               </a:ext>
             </a:extLst>
           </p:cNvPr>
@@ -9314,7 +9407,7 @@
           <p:cNvPr id="4" name="">
             <a:extLst xmlns:a="http://schemas.openxmlformats.org/drawingml/2006/main">
               <a:ext uri="{FF2B5EF4-FFF2-40B4-BE49-F238E27FC236}">
-                <a16:creationId xmlns:a16="http://schemas.microsoft.com/office/drawing/2014/main" id="{C1B8ECBE-FB8B-4E70-928B-93DE5B6DCC4C}"/>
+                <a16:creationId xmlns:a16="http://schemas.microsoft.com/office/drawing/2014/main" id="{43637E17-4CA3-44BA-A91F-2117BE265B97}"/>
               </a:ext>
             </a:extLst>
           </p:cNvPr>
@@ -9379,7 +9472,7 @@
           <p:nvPr/>
         </p:nvPicPr>
         <p:blipFill>
-          <a:blip xmlns:r="http://schemas.openxmlformats.org/officeDocument/2006/relationships" xmlns:a="http://schemas.openxmlformats.org/drawingml/2006/main" r:embed="Rea347b6711534ccd"/>
+          <a:blip xmlns:r="http://schemas.openxmlformats.org/officeDocument/2006/relationships" xmlns:a="http://schemas.openxmlformats.org/drawingml/2006/main" r:embed="R7b7d6fbdc97a4cf3"/>
           <a:stretch xmlns:a="http://schemas.openxmlformats.org/drawingml/2006/main"/>
         </p:blipFill>
         <p:spPr>
@@ -9397,7 +9490,7 @@
           <p:cNvPr id="6" name="">
             <a:extLst xmlns:a="http://schemas.openxmlformats.org/drawingml/2006/main">
               <a:ext uri="{FF2B5EF4-FFF2-40B4-BE49-F238E27FC236}">
-                <a16:creationId xmlns:a16="http://schemas.microsoft.com/office/drawing/2014/main" id="{F317CC44-B0BD-4712-99AD-7087D1CE7A99}"/>
+                <a16:creationId xmlns:a16="http://schemas.microsoft.com/office/drawing/2014/main" id="{EF27C360-D9C1-450E-B070-81764F6EA2FF}"/>
               </a:ext>
             </a:extLst>
           </p:cNvPr>
@@ -9431,7 +9524,7 @@
           <p:cNvPr id="7" name="">
             <a:extLst xmlns:a="http://schemas.openxmlformats.org/drawingml/2006/main">
               <a:ext uri="{FF2B5EF4-FFF2-40B4-BE49-F238E27FC236}">
-                <a16:creationId xmlns:a16="http://schemas.microsoft.com/office/drawing/2014/main" id="{8FD55909-2206-49E3-87D0-A9B30A8AFDC8}"/>
+                <a16:creationId xmlns:a16="http://schemas.microsoft.com/office/drawing/2014/main" id="{09147184-E5A2-4DA5-9954-A6AE8A049169}"/>
               </a:ext>
             </a:extLst>
           </p:cNvPr>
@@ -9492,7 +9585,7 @@
           <p:cNvPr id="8" name="">
             <a:extLst xmlns:a="http://schemas.openxmlformats.org/drawingml/2006/main">
               <a:ext uri="{FF2B5EF4-FFF2-40B4-BE49-F238E27FC236}">
-                <a16:creationId xmlns:a16="http://schemas.microsoft.com/office/drawing/2014/main" id="{50A4FB8A-D794-4913-895D-771393A6FE65}"/>
+                <a16:creationId xmlns:a16="http://schemas.microsoft.com/office/drawing/2014/main" id="{3962E079-F5EA-4FC2-B059-EFD2146CE356}"/>
               </a:ext>
             </a:extLst>
           </p:cNvPr>
@@ -9553,7 +9646,7 @@
           <p:cNvPr id="9" name="">
             <a:extLst xmlns:a="http://schemas.openxmlformats.org/drawingml/2006/main">
               <a:ext uri="{FF2B5EF4-FFF2-40B4-BE49-F238E27FC236}">
-                <a16:creationId xmlns:a16="http://schemas.microsoft.com/office/drawing/2014/main" id="{732A923F-32B8-4CF9-B665-A6BDDB65916D}"/>
+                <a16:creationId xmlns:a16="http://schemas.microsoft.com/office/drawing/2014/main" id="{A9891CE3-D8DF-42EF-8F32-A439DA51ECCD}"/>
               </a:ext>
             </a:extLst>
           </p:cNvPr>
@@ -9614,7 +9707,7 @@
           <p:cNvPr id="10" name="">
             <a:extLst xmlns:a="http://schemas.openxmlformats.org/drawingml/2006/main">
               <a:ext uri="{FF2B5EF4-FFF2-40B4-BE49-F238E27FC236}">
-                <a16:creationId xmlns:a16="http://schemas.microsoft.com/office/drawing/2014/main" id="{08300759-39E3-4CF1-820E-A11602EAD414}"/>
+                <a16:creationId xmlns:a16="http://schemas.microsoft.com/office/drawing/2014/main" id="{F93A9BB5-67E1-4FDE-BC03-81840979CD6F}"/>
               </a:ext>
             </a:extLst>
           </p:cNvPr>
@@ -9648,7 +9741,7 @@
           <p:cNvPr id="11" name="">
             <a:extLst xmlns:a="http://schemas.openxmlformats.org/drawingml/2006/main">
               <a:ext uri="{FF2B5EF4-FFF2-40B4-BE49-F238E27FC236}">
-                <a16:creationId xmlns:a16="http://schemas.microsoft.com/office/drawing/2014/main" id="{1345081A-BC6A-4C65-B072-FFA6C3951AA3}"/>
+                <a16:creationId xmlns:a16="http://schemas.microsoft.com/office/drawing/2014/main" id="{0A646E25-AB48-467E-93AA-98DA35C14B7D}"/>
               </a:ext>
             </a:extLst>
           </p:cNvPr>
@@ -9709,7 +9802,7 @@
           <p:cNvPr id="12" name="">
             <a:extLst xmlns:a="http://schemas.openxmlformats.org/drawingml/2006/main">
               <a:ext uri="{FF2B5EF4-FFF2-40B4-BE49-F238E27FC236}">
-                <a16:creationId xmlns:a16="http://schemas.microsoft.com/office/drawing/2014/main" id="{DB6548DB-2197-47E4-805B-5199FB458C2B}"/>
+                <a16:creationId xmlns:a16="http://schemas.microsoft.com/office/drawing/2014/main" id="{017159E8-E07A-42E6-8D2E-AEE4CE41B15B}"/>
               </a:ext>
             </a:extLst>
           </p:cNvPr>
@@ -9851,7 +9944,7 @@
           <p:cNvPr id="13" name="">
             <a:extLst xmlns:a="http://schemas.openxmlformats.org/drawingml/2006/main">
               <a:ext uri="{FF2B5EF4-FFF2-40B4-BE49-F238E27FC236}">
-                <a16:creationId xmlns:a16="http://schemas.microsoft.com/office/drawing/2014/main" id="{F35BEFAB-1C48-406F-98A0-D113E5455B98}"/>
+                <a16:creationId xmlns:a16="http://schemas.microsoft.com/office/drawing/2014/main" id="{CEF54F0A-1CDB-4752-9C96-C3FA08153696}"/>
               </a:ext>
             </a:extLst>
           </p:cNvPr>
@@ -9910,7 +10003,7 @@
     </p:spTree>
     <p:extLst>
       <p:ext uri="{BB962C8B-B14F-4D97-AF65-F5344CB8AC3E}">
-        <p14:creationId xmlns:p14="http://schemas.microsoft.com/office/powerpoint/2010/main" val="1625675367"/>
+        <p14:creationId xmlns:p14="http://schemas.microsoft.com/office/powerpoint/2010/main" val="1755346213"/>
       </p:ext>
     </p:extLst>
   </p:cSld>
@@ -9941,7 +10034,7 @@
           <p:cNvPr id="15" name="">
             <a:extLst xmlns:a="http://schemas.openxmlformats.org/drawingml/2006/main">
               <a:ext uri="{FF2B5EF4-FFF2-40B4-BE49-F238E27FC236}">
-                <a16:creationId xmlns:a16="http://schemas.microsoft.com/office/drawing/2014/main" id="{92565159-F534-450A-9E0D-E614FF783A4C}"/>
+                <a16:creationId xmlns:a16="http://schemas.microsoft.com/office/drawing/2014/main" id="{7B5A002B-3B7A-4D2E-9A6A-A3C39C5B0BC7}"/>
               </a:ext>
             </a:extLst>
           </p:cNvPr>
@@ -10002,7 +10095,7 @@
           <p:cNvPr id="2" name="">
             <a:extLst xmlns:a="http://schemas.openxmlformats.org/drawingml/2006/main">
               <a:ext uri="{FF2B5EF4-FFF2-40B4-BE49-F238E27FC236}">
-                <a16:creationId xmlns:a16="http://schemas.microsoft.com/office/drawing/2014/main" id="{ED8CF314-CC16-4DF7-927B-B179C62995DB}"/>
+                <a16:creationId xmlns:a16="http://schemas.microsoft.com/office/drawing/2014/main" id="{64315C03-185F-4E8F-878A-9099C7C582D1}"/>
               </a:ext>
             </a:extLst>
           </p:cNvPr>
@@ -10063,7 +10156,7 @@
           <p:cNvPr id="3" name="">
             <a:extLst xmlns:a="http://schemas.openxmlformats.org/drawingml/2006/main">
               <a:ext uri="{FF2B5EF4-FFF2-40B4-BE49-F238E27FC236}">
-                <a16:creationId xmlns:a16="http://schemas.microsoft.com/office/drawing/2014/main" id="{9EA83102-8C6E-4BEF-97CF-01C8294D8495}"/>
+                <a16:creationId xmlns:a16="http://schemas.microsoft.com/office/drawing/2014/main" id="{77B6EF63-6751-4DC3-86BE-41AB3CC453D3}"/>
               </a:ext>
             </a:extLst>
           </p:cNvPr>
@@ -10093,7 +10186,7 @@
           <p:cNvPr id="4" name="">
             <a:extLst xmlns:a="http://schemas.openxmlformats.org/drawingml/2006/main">
               <a:ext uri="{FF2B5EF4-FFF2-40B4-BE49-F238E27FC236}">
-                <a16:creationId xmlns:a16="http://schemas.microsoft.com/office/drawing/2014/main" id="{4513BFF6-7938-406D-BD8B-09AD81DEA686}"/>
+                <a16:creationId xmlns:a16="http://schemas.microsoft.com/office/drawing/2014/main" id="{D44AB404-C493-4F55-8439-1AA137E9FD23}"/>
               </a:ext>
             </a:extLst>
           </p:cNvPr>
@@ -10154,7 +10247,7 @@
           <p:cNvPr id="5" name="">
             <a:extLst xmlns:a="http://schemas.openxmlformats.org/drawingml/2006/main">
               <a:ext uri="{FF2B5EF4-FFF2-40B4-BE49-F238E27FC236}">
-                <a16:creationId xmlns:a16="http://schemas.microsoft.com/office/drawing/2014/main" id="{C3FAF111-7ADB-4D8D-8244-B0B41805C553}"/>
+                <a16:creationId xmlns:a16="http://schemas.microsoft.com/office/drawing/2014/main" id="{3D63C4C2-6A54-4E75-AEBD-E81B38E052E5}"/>
               </a:ext>
             </a:extLst>
           </p:cNvPr>
@@ -10188,7 +10281,7 @@
           <p:cNvPr id="6" name="">
             <a:extLst xmlns:a="http://schemas.openxmlformats.org/drawingml/2006/main">
               <a:ext uri="{FF2B5EF4-FFF2-40B4-BE49-F238E27FC236}">
-                <a16:creationId xmlns:a16="http://schemas.microsoft.com/office/drawing/2014/main" id="{7653D063-2364-4DA3-83F0-9AB30ED0A9E0}"/>
+                <a16:creationId xmlns:a16="http://schemas.microsoft.com/office/drawing/2014/main" id="{8F8717AD-E57D-4192-AC3E-EE82CADAC698}"/>
               </a:ext>
             </a:extLst>
           </p:cNvPr>
@@ -10249,7 +10342,7 @@
           <p:cNvPr id="7" name="">
             <a:extLst xmlns:a="http://schemas.openxmlformats.org/drawingml/2006/main">
               <a:ext uri="{FF2B5EF4-FFF2-40B4-BE49-F238E27FC236}">
-                <a16:creationId xmlns:a16="http://schemas.microsoft.com/office/drawing/2014/main" id="{4D945D87-BF14-4D1A-A192-8B781D5FFEAB}"/>
+                <a16:creationId xmlns:a16="http://schemas.microsoft.com/office/drawing/2014/main" id="{D8A0A679-4629-4175-AE64-C3454718A692}"/>
               </a:ext>
             </a:extLst>
           </p:cNvPr>
@@ -10310,7 +10403,7 @@
           <p:cNvPr id="8" name="">
             <a:extLst xmlns:a="http://schemas.openxmlformats.org/drawingml/2006/main">
               <a:ext uri="{FF2B5EF4-FFF2-40B4-BE49-F238E27FC236}">
-                <a16:creationId xmlns:a16="http://schemas.microsoft.com/office/drawing/2014/main" id="{470888BD-9ECE-4C75-8AE5-793D0CB2C3DE}"/>
+                <a16:creationId xmlns:a16="http://schemas.microsoft.com/office/drawing/2014/main" id="{098A69E9-F9A2-4D0F-B565-866CF5A79587}"/>
               </a:ext>
             </a:extLst>
           </p:cNvPr>
@@ -10344,7 +10437,7 @@
           <p:cNvPr id="9" name="">
             <a:extLst xmlns:a="http://schemas.openxmlformats.org/drawingml/2006/main">
               <a:ext uri="{FF2B5EF4-FFF2-40B4-BE49-F238E27FC236}">
-                <a16:creationId xmlns:a16="http://schemas.microsoft.com/office/drawing/2014/main" id="{981E7FD3-055A-4258-A679-8122C15DAA47}"/>
+                <a16:creationId xmlns:a16="http://schemas.microsoft.com/office/drawing/2014/main" id="{14940686-358A-47A2-A742-25EB2BEC8500}"/>
               </a:ext>
             </a:extLst>
           </p:cNvPr>
@@ -10405,7 +10498,7 @@
           <p:cNvPr id="10" name="">
             <a:extLst xmlns:a="http://schemas.openxmlformats.org/drawingml/2006/main">
               <a:ext uri="{FF2B5EF4-FFF2-40B4-BE49-F238E27FC236}">
-                <a16:creationId xmlns:a16="http://schemas.microsoft.com/office/drawing/2014/main" id="{73B9DE85-DEE7-41FE-9C34-67B0860A9D52}"/>
+                <a16:creationId xmlns:a16="http://schemas.microsoft.com/office/drawing/2014/main" id="{F05700F7-AF18-4934-9C99-9A7D1ADCFE6B}"/>
               </a:ext>
             </a:extLst>
           </p:cNvPr>
@@ -10466,7 +10559,7 @@
           <p:cNvPr id="11" name="">
             <a:extLst xmlns:a="http://schemas.openxmlformats.org/drawingml/2006/main">
               <a:ext uri="{FF2B5EF4-FFF2-40B4-BE49-F238E27FC236}">
-                <a16:creationId xmlns:a16="http://schemas.microsoft.com/office/drawing/2014/main" id="{CA324857-978E-426F-B7D7-F6EF0121759D}"/>
+                <a16:creationId xmlns:a16="http://schemas.microsoft.com/office/drawing/2014/main" id="{E7370A3D-6D8C-4D4E-B72C-50DA8E79D90F}"/>
               </a:ext>
             </a:extLst>
           </p:cNvPr>
@@ -10527,7 +10620,7 @@
           <p:cNvPr id="12" name="">
             <a:extLst xmlns:a="http://schemas.openxmlformats.org/drawingml/2006/main">
               <a:ext uri="{FF2B5EF4-FFF2-40B4-BE49-F238E27FC236}">
-                <a16:creationId xmlns:a16="http://schemas.microsoft.com/office/drawing/2014/main" id="{21467CA5-D876-4B71-A84F-F23319AEB9ED}"/>
+                <a16:creationId xmlns:a16="http://schemas.microsoft.com/office/drawing/2014/main" id="{2C8C96E8-1FDD-4F80-9031-FAEDFFE3E083}"/>
               </a:ext>
             </a:extLst>
           </p:cNvPr>
@@ -10588,7 +10681,7 @@
           <p:cNvPr id="13" name="">
             <a:extLst xmlns:a="http://schemas.openxmlformats.org/drawingml/2006/main">
               <a:ext uri="{FF2B5EF4-FFF2-40B4-BE49-F238E27FC236}">
-                <a16:creationId xmlns:a16="http://schemas.microsoft.com/office/drawing/2014/main" id="{186EFDBE-A04F-43AD-8176-0B931B712D5C}"/>
+                <a16:creationId xmlns:a16="http://schemas.microsoft.com/office/drawing/2014/main" id="{30778563-451F-4EC4-86CA-7F8159D6D11A}"/>
               </a:ext>
             </a:extLst>
           </p:cNvPr>
@@ -10649,7 +10742,7 @@
           <p:cNvPr id="14" name="">
             <a:extLst xmlns:a="http://schemas.openxmlformats.org/drawingml/2006/main">
               <a:ext uri="{FF2B5EF4-FFF2-40B4-BE49-F238E27FC236}">
-                <a16:creationId xmlns:a16="http://schemas.microsoft.com/office/drawing/2014/main" id="{2D25B50C-216B-439B-A0A4-0034497E2D7D}"/>
+                <a16:creationId xmlns:a16="http://schemas.microsoft.com/office/drawing/2014/main" id="{4AFE4801-2C28-4533-ABB8-459700303B3C}"/>
               </a:ext>
             </a:extLst>
           </p:cNvPr>
@@ -10708,7 +10801,7 @@
     </p:spTree>
     <p:extLst>
       <p:ext uri="{BB962C8B-B14F-4D97-AF65-F5344CB8AC3E}">
-        <p14:creationId xmlns:p14="http://schemas.microsoft.com/office/powerpoint/2010/main" val="1802120828"/>
+        <p14:creationId xmlns:p14="http://schemas.microsoft.com/office/powerpoint/2010/main" val="804352027"/>
       </p:ext>
     </p:extLst>
   </p:cSld>
@@ -10739,7 +10832,7 @@
           <p:cNvPr id="14" name="">
             <a:extLst xmlns:a="http://schemas.openxmlformats.org/drawingml/2006/main">
               <a:ext uri="{FF2B5EF4-FFF2-40B4-BE49-F238E27FC236}">
-                <a16:creationId xmlns:a16="http://schemas.microsoft.com/office/drawing/2014/main" id="{B818A317-A739-4FAA-A0DF-A18CAE0C8E59}"/>
+                <a16:creationId xmlns:a16="http://schemas.microsoft.com/office/drawing/2014/main" id="{02428635-0120-4E42-BB49-4A57D6C05F77}"/>
               </a:ext>
             </a:extLst>
           </p:cNvPr>
@@ -10800,7 +10893,7 @@
           <p:cNvPr id="2" name="">
             <a:extLst xmlns:a="http://schemas.openxmlformats.org/drawingml/2006/main">
               <a:ext uri="{FF2B5EF4-FFF2-40B4-BE49-F238E27FC236}">
-                <a16:creationId xmlns:a16="http://schemas.microsoft.com/office/drawing/2014/main" id="{58E4EC47-301E-44BA-8044-F5F1BD5569CE}"/>
+                <a16:creationId xmlns:a16="http://schemas.microsoft.com/office/drawing/2014/main" id="{E78DD208-5F0F-4464-A681-BFC107A42B72}"/>
               </a:ext>
             </a:extLst>
           </p:cNvPr>
@@ -10861,7 +10954,7 @@
           <p:cNvPr id="3" name="">
             <a:extLst xmlns:a="http://schemas.openxmlformats.org/drawingml/2006/main">
               <a:ext uri="{FF2B5EF4-FFF2-40B4-BE49-F238E27FC236}">
-                <a16:creationId xmlns:a16="http://schemas.microsoft.com/office/drawing/2014/main" id="{E390F762-A6D0-462E-80AB-1B211B97DDA5}"/>
+                <a16:creationId xmlns:a16="http://schemas.microsoft.com/office/drawing/2014/main" id="{9244C386-87BE-4C70-83D9-A6B1DF88E561}"/>
               </a:ext>
             </a:extLst>
           </p:cNvPr>
@@ -10891,7 +10984,7 @@
           <p:cNvPr id="4" name="">
             <a:extLst xmlns:a="http://schemas.openxmlformats.org/drawingml/2006/main">
               <a:ext uri="{FF2B5EF4-FFF2-40B4-BE49-F238E27FC236}">
-                <a16:creationId xmlns:a16="http://schemas.microsoft.com/office/drawing/2014/main" id="{B5E6CD25-C2AB-4F3E-80E8-E1D94372738F}"/>
+                <a16:creationId xmlns:a16="http://schemas.microsoft.com/office/drawing/2014/main" id="{8F343AAC-FE70-4C64-A82D-C076485AAEB9}"/>
               </a:ext>
             </a:extLst>
           </p:cNvPr>
@@ -10952,7 +11045,7 @@
           <p:cNvPr id="5" name="">
             <a:extLst xmlns:a="http://schemas.openxmlformats.org/drawingml/2006/main">
               <a:ext uri="{FF2B5EF4-FFF2-40B4-BE49-F238E27FC236}">
-                <a16:creationId xmlns:a16="http://schemas.microsoft.com/office/drawing/2014/main" id="{159CD02C-BCB0-4C93-874F-02B2E9675E3D}"/>
+                <a16:creationId xmlns:a16="http://schemas.microsoft.com/office/drawing/2014/main" id="{0EB9B353-91F9-4CD2-9678-7580940B03D5}"/>
               </a:ext>
             </a:extLst>
           </p:cNvPr>
@@ -11013,7 +11106,7 @@
           <p:cNvPr id="6" name="">
             <a:extLst xmlns:a="http://schemas.openxmlformats.org/drawingml/2006/main">
               <a:ext uri="{FF2B5EF4-FFF2-40B4-BE49-F238E27FC236}">
-                <a16:creationId xmlns:a16="http://schemas.microsoft.com/office/drawing/2014/main" id="{9C118BF4-496F-4284-8705-870537CBA93C}"/>
+                <a16:creationId xmlns:a16="http://schemas.microsoft.com/office/drawing/2014/main" id="{1D34A93D-36C6-4C6A-A51E-9093A341B9ED}"/>
               </a:ext>
             </a:extLst>
           </p:cNvPr>
@@ -11074,7 +11167,7 @@
           <p:cNvPr id="7" name="">
             <a:extLst xmlns:a="http://schemas.openxmlformats.org/drawingml/2006/main">
               <a:ext uri="{FF2B5EF4-FFF2-40B4-BE49-F238E27FC236}">
-                <a16:creationId xmlns:a16="http://schemas.microsoft.com/office/drawing/2014/main" id="{CD0536B3-3CFA-4B5D-BCA6-E530FD8B81AE}"/>
+                <a16:creationId xmlns:a16="http://schemas.microsoft.com/office/drawing/2014/main" id="{00EED77E-D1FB-4528-82E6-BF40CCAE3094}"/>
               </a:ext>
             </a:extLst>
           </p:cNvPr>
@@ -11135,7 +11228,7 @@
           <p:cNvPr id="8" name="">
             <a:extLst xmlns:a="http://schemas.openxmlformats.org/drawingml/2006/main">
               <a:ext uri="{FF2B5EF4-FFF2-40B4-BE49-F238E27FC236}">
-                <a16:creationId xmlns:a16="http://schemas.microsoft.com/office/drawing/2014/main" id="{EE79B28F-5B3B-4513-BF62-DB7655FEB9F0}"/>
+                <a16:creationId xmlns:a16="http://schemas.microsoft.com/office/drawing/2014/main" id="{9E5A596D-5999-4724-B588-CA4028CE30EA}"/>
               </a:ext>
             </a:extLst>
           </p:cNvPr>
@@ -11196,7 +11289,7 @@
           <p:cNvPr id="9" name="">
             <a:extLst xmlns:a="http://schemas.openxmlformats.org/drawingml/2006/main">
               <a:ext uri="{FF2B5EF4-FFF2-40B4-BE49-F238E27FC236}">
-                <a16:creationId xmlns:a16="http://schemas.microsoft.com/office/drawing/2014/main" id="{BF8347B3-98EF-4F7E-98A1-29948946285C}"/>
+                <a16:creationId xmlns:a16="http://schemas.microsoft.com/office/drawing/2014/main" id="{E94B412D-1239-494E-84E1-6940E7B4988A}"/>
               </a:ext>
             </a:extLst>
           </p:cNvPr>
@@ -11257,7 +11350,7 @@
           <p:cNvPr id="10" name="">
             <a:extLst xmlns:a="http://schemas.openxmlformats.org/drawingml/2006/main">
               <a:ext uri="{FF2B5EF4-FFF2-40B4-BE49-F238E27FC236}">
-                <a16:creationId xmlns:a16="http://schemas.microsoft.com/office/drawing/2014/main" id="{3CF002D5-FD86-4B58-AE10-27AD1250C4CD}"/>
+                <a16:creationId xmlns:a16="http://schemas.microsoft.com/office/drawing/2014/main" id="{6E4E1340-81A8-4088-932C-8651A0C4B166}"/>
               </a:ext>
             </a:extLst>
           </p:cNvPr>
@@ -11318,7 +11411,7 @@
           <p:cNvPr id="11" name="">
             <a:extLst xmlns:a="http://schemas.openxmlformats.org/drawingml/2006/main">
               <a:ext uri="{FF2B5EF4-FFF2-40B4-BE49-F238E27FC236}">
-                <a16:creationId xmlns:a16="http://schemas.microsoft.com/office/drawing/2014/main" id="{CFB2B1F0-8C5F-44D8-A165-FD5E237A5419}"/>
+                <a16:creationId xmlns:a16="http://schemas.microsoft.com/office/drawing/2014/main" id="{ED202566-68B5-49F6-B69C-A8256F635234}"/>
               </a:ext>
             </a:extLst>
           </p:cNvPr>
@@ -11379,7 +11472,7 @@
           <p:cNvPr id="12" name="">
             <a:extLst xmlns:a="http://schemas.openxmlformats.org/drawingml/2006/main">
               <a:ext uri="{FF2B5EF4-FFF2-40B4-BE49-F238E27FC236}">
-                <a16:creationId xmlns:a16="http://schemas.microsoft.com/office/drawing/2014/main" id="{BDD00BB4-6319-4A1C-AA7D-4A405B62DD87}"/>
+                <a16:creationId xmlns:a16="http://schemas.microsoft.com/office/drawing/2014/main" id="{DFBF4A01-1E1A-47C4-9BD7-40B84F344267}"/>
               </a:ext>
             </a:extLst>
           </p:cNvPr>
@@ -11440,7 +11533,7 @@
           <p:cNvPr id="13" name="">
             <a:extLst xmlns:a="http://schemas.openxmlformats.org/drawingml/2006/main">
               <a:ext uri="{FF2B5EF4-FFF2-40B4-BE49-F238E27FC236}">
-                <a16:creationId xmlns:a16="http://schemas.microsoft.com/office/drawing/2014/main" id="{733F19AA-106C-4595-AB83-95BA64B7884C}"/>
+                <a16:creationId xmlns:a16="http://schemas.microsoft.com/office/drawing/2014/main" id="{9AB55407-3D66-4CF2-BE5D-5A0F610B0BC2}"/>
               </a:ext>
             </a:extLst>
           </p:cNvPr>
@@ -11499,7 +11592,7 @@
     </p:spTree>
     <p:extLst>
       <p:ext uri="{BB962C8B-B14F-4D97-AF65-F5344CB8AC3E}">
-        <p14:creationId xmlns:p14="http://schemas.microsoft.com/office/powerpoint/2010/main" val="1231024261"/>
+        <p14:creationId xmlns:p14="http://schemas.microsoft.com/office/powerpoint/2010/main" val="1237912092"/>
       </p:ext>
     </p:extLst>
   </p:cSld>

</xml_diff>